<commit_message>
sketching out lab 8
</commit_message>
<xml_diff>
--- a/8_categorical_indicators/figures/demo8_diagrams.pptx
+++ b/8_categorical_indicators/figures/demo8_diagrams.pptx
@@ -200,7 +200,7 @@
           <a:p>
             <a:fld id="{FA914575-E7EC-47B9-974E-E63DD587881C}" type="datetimeFigureOut">
               <a:rPr lang="en-US" smtClean="0"/>
-              <a:t>7/14/2023</a:t>
+              <a:t>3/16/2026</a:t>
             </a:fld>
             <a:endParaRPr lang="en-US"/>
           </a:p>
@@ -598,7 +598,7 @@
           <a:p>
             <a:fld id="{D0117812-9019-4EF8-BBCE-D5F16AD1EFE7}" type="datetimeFigureOut">
               <a:rPr lang="en-US" smtClean="0"/>
-              <a:t>7/14/2023</a:t>
+              <a:t>3/16/2026</a:t>
             </a:fld>
             <a:endParaRPr lang="en-US"/>
           </a:p>
@@ -768,7 +768,7 @@
           <a:p>
             <a:fld id="{D0117812-9019-4EF8-BBCE-D5F16AD1EFE7}" type="datetimeFigureOut">
               <a:rPr lang="en-US" smtClean="0"/>
-              <a:t>7/14/2023</a:t>
+              <a:t>3/16/2026</a:t>
             </a:fld>
             <a:endParaRPr lang="en-US"/>
           </a:p>
@@ -948,7 +948,7 @@
           <a:p>
             <a:fld id="{D0117812-9019-4EF8-BBCE-D5F16AD1EFE7}" type="datetimeFigureOut">
               <a:rPr lang="en-US" smtClean="0"/>
-              <a:t>7/14/2023</a:t>
+              <a:t>3/16/2026</a:t>
             </a:fld>
             <a:endParaRPr lang="en-US"/>
           </a:p>
@@ -1118,7 +1118,7 @@
           <a:p>
             <a:fld id="{D0117812-9019-4EF8-BBCE-D5F16AD1EFE7}" type="datetimeFigureOut">
               <a:rPr lang="en-US" smtClean="0"/>
-              <a:t>7/14/2023</a:t>
+              <a:t>3/16/2026</a:t>
             </a:fld>
             <a:endParaRPr lang="en-US"/>
           </a:p>
@@ -1364,7 +1364,7 @@
           <a:p>
             <a:fld id="{D0117812-9019-4EF8-BBCE-D5F16AD1EFE7}" type="datetimeFigureOut">
               <a:rPr lang="en-US" smtClean="0"/>
-              <a:t>7/14/2023</a:t>
+              <a:t>3/16/2026</a:t>
             </a:fld>
             <a:endParaRPr lang="en-US"/>
           </a:p>
@@ -1596,7 +1596,7 @@
           <a:p>
             <a:fld id="{D0117812-9019-4EF8-BBCE-D5F16AD1EFE7}" type="datetimeFigureOut">
               <a:rPr lang="en-US" smtClean="0"/>
-              <a:t>7/14/2023</a:t>
+              <a:t>3/16/2026</a:t>
             </a:fld>
             <a:endParaRPr lang="en-US"/>
           </a:p>
@@ -1963,7 +1963,7 @@
           <a:p>
             <a:fld id="{D0117812-9019-4EF8-BBCE-D5F16AD1EFE7}" type="datetimeFigureOut">
               <a:rPr lang="en-US" smtClean="0"/>
-              <a:t>7/14/2023</a:t>
+              <a:t>3/16/2026</a:t>
             </a:fld>
             <a:endParaRPr lang="en-US"/>
           </a:p>
@@ -2081,7 +2081,7 @@
           <a:p>
             <a:fld id="{D0117812-9019-4EF8-BBCE-D5F16AD1EFE7}" type="datetimeFigureOut">
               <a:rPr lang="en-US" smtClean="0"/>
-              <a:t>7/14/2023</a:t>
+              <a:t>3/16/2026</a:t>
             </a:fld>
             <a:endParaRPr lang="en-US"/>
           </a:p>
@@ -2176,7 +2176,7 @@
           <a:p>
             <a:fld id="{D0117812-9019-4EF8-BBCE-D5F16AD1EFE7}" type="datetimeFigureOut">
               <a:rPr lang="en-US" smtClean="0"/>
-              <a:t>7/14/2023</a:t>
+              <a:t>3/16/2026</a:t>
             </a:fld>
             <a:endParaRPr lang="en-US"/>
           </a:p>
@@ -2453,7 +2453,7 @@
           <a:p>
             <a:fld id="{D0117812-9019-4EF8-BBCE-D5F16AD1EFE7}" type="datetimeFigureOut">
               <a:rPr lang="en-US" smtClean="0"/>
-              <a:t>7/14/2023</a:t>
+              <a:t>3/16/2026</a:t>
             </a:fld>
             <a:endParaRPr lang="en-US"/>
           </a:p>
@@ -2710,7 +2710,7 @@
           <a:p>
             <a:fld id="{D0117812-9019-4EF8-BBCE-D5F16AD1EFE7}" type="datetimeFigureOut">
               <a:rPr lang="en-US" smtClean="0"/>
-              <a:t>7/14/2023</a:t>
+              <a:t>3/16/2026</a:t>
             </a:fld>
             <a:endParaRPr lang="en-US"/>
           </a:p>
@@ -2923,7 +2923,7 @@
           <a:p>
             <a:fld id="{D0117812-9019-4EF8-BBCE-D5F16AD1EFE7}" type="datetimeFigureOut">
               <a:rPr lang="en-US" smtClean="0"/>
-              <a:t>7/14/2023</a:t>
+              <a:t>3/16/2026</a:t>
             </a:fld>
             <a:endParaRPr lang="en-US"/>
           </a:p>
@@ -3328,1938 +3328,1882 @@
           <a:chExt cx="0" cy="0"/>
         </a:xfrm>
       </p:grpSpPr>
-      <p:grpSp>
-        <p:nvGrpSpPr>
-          <p:cNvPr id="122" name="Group 121">
+      <p:sp>
+        <p:nvSpPr>
+          <p:cNvPr id="88" name="Rectangle 87">
             <a:extLst>
               <a:ext uri="{FF2B5EF4-FFF2-40B4-BE49-F238E27FC236}">
-                <a16:creationId xmlns:a16="http://schemas.microsoft.com/office/drawing/2014/main" id="{9A4F3F8A-1F8D-CCE6-236F-84EDEF8901C0}"/>
+                <a16:creationId xmlns:a16="http://schemas.microsoft.com/office/drawing/2014/main" id="{9721BF25-5F46-4E94-B8B0-EF76B1988557}"/>
               </a:ext>
             </a:extLst>
           </p:cNvPr>
-          <p:cNvGrpSpPr/>
+          <p:cNvSpPr/>
           <p:nvPr/>
-        </p:nvGrpSpPr>
-        <p:grpSpPr>
+        </p:nvSpPr>
+        <p:spPr>
           <a:xfrm>
-            <a:off x="728116" y="844483"/>
-            <a:ext cx="7500802" cy="4238812"/>
-            <a:chOff x="728116" y="844483"/>
-            <a:chExt cx="7500802" cy="4238812"/>
+            <a:off x="728116" y="3393175"/>
+            <a:ext cx="765907" cy="749885"/>
           </a:xfrm>
-        </p:grpSpPr>
-        <p:grpSp>
-          <p:nvGrpSpPr>
-            <p:cNvPr id="58" name="Group 57">
-              <a:extLst>
-                <a:ext uri="{FF2B5EF4-FFF2-40B4-BE49-F238E27FC236}">
-                  <a16:creationId xmlns:a16="http://schemas.microsoft.com/office/drawing/2014/main" id="{9D6E8230-38F2-543A-1718-5CD60664FE4A}"/>
-                </a:ext>
-              </a:extLst>
-            </p:cNvPr>
-            <p:cNvGrpSpPr/>
-            <p:nvPr/>
-          </p:nvGrpSpPr>
-          <p:grpSpPr>
-            <a:xfrm>
-              <a:off x="728116" y="850832"/>
-              <a:ext cx="2897027" cy="4232463"/>
-              <a:chOff x="2714205" y="2107653"/>
-              <a:chExt cx="2897027" cy="4232463"/>
-            </a:xfrm>
-          </p:grpSpPr>
-          <p:sp>
-            <p:nvSpPr>
-              <p:cNvPr id="88" name="Rectangle 87">
-                <a:extLst>
-                  <a:ext uri="{FF2B5EF4-FFF2-40B4-BE49-F238E27FC236}">
-                    <a16:creationId xmlns:a16="http://schemas.microsoft.com/office/drawing/2014/main" id="{9721BF25-5F46-4E94-B8B0-EF76B1988557}"/>
-                  </a:ext>
-                </a:extLst>
-              </p:cNvPr>
-              <p:cNvSpPr/>
-              <p:nvPr/>
-            </p:nvSpPr>
-            <p:spPr>
-              <a:xfrm>
-                <a:off x="2714205" y="4649996"/>
-                <a:ext cx="765907" cy="749885"/>
-              </a:xfrm>
-              <a:prstGeom prst="rect">
-                <a:avLst/>
-              </a:prstGeom>
-              <a:solidFill>
-                <a:schemeClr val="bg1"/>
-              </a:solidFill>
-              <a:ln w="19050">
+          <a:prstGeom prst="rect">
+            <a:avLst/>
+          </a:prstGeom>
+          <a:solidFill>
+            <a:schemeClr val="bg1"/>
+          </a:solidFill>
+          <a:ln w="19050">
+            <a:solidFill>
+              <a:schemeClr val="tx1"/>
+            </a:solidFill>
+          </a:ln>
+        </p:spPr>
+        <p:style>
+          <a:lnRef idx="2">
+            <a:schemeClr val="accent1">
+              <a:shade val="50000"/>
+            </a:schemeClr>
+          </a:lnRef>
+          <a:fillRef idx="1">
+            <a:schemeClr val="accent1"/>
+          </a:fillRef>
+          <a:effectRef idx="0">
+            <a:schemeClr val="accent1"/>
+          </a:effectRef>
+          <a:fontRef idx="minor">
+            <a:schemeClr val="lt1"/>
+          </a:fontRef>
+        </p:style>
+        <p:txBody>
+          <a:bodyPr rot="0" spcFirstLastPara="0" vertOverflow="overflow" horzOverflow="overflow" vert="horz" wrap="square" lIns="53996" tIns="26998" rIns="53996" bIns="26998" numCol="1" spcCol="0" rtlCol="0" fromWordArt="0" anchor="ctr" anchorCtr="0" forceAA="0" compatLnSpc="1">
+            <a:prstTxWarp prst="textNoShape">
+              <a:avLst/>
+            </a:prstTxWarp>
+            <a:noAutofit/>
+          </a:bodyPr>
+          <a:lstStyle/>
+          <a:p>
+            <a:pPr algn="ctr"/>
+            <a:r>
+              <a:rPr lang="en-US" dirty="0">
                 <a:solidFill>
                   <a:schemeClr val="tx1"/>
                 </a:solidFill>
-              </a:ln>
-            </p:spPr>
-            <p:style>
-              <a:lnRef idx="2">
-                <a:schemeClr val="accent1">
-                  <a:shade val="50000"/>
-                </a:schemeClr>
-              </a:lnRef>
-              <a:fillRef idx="1">
-                <a:schemeClr val="accent1"/>
-              </a:fillRef>
-              <a:effectRef idx="0">
-                <a:schemeClr val="accent1"/>
-              </a:effectRef>
-              <a:fontRef idx="minor">
-                <a:schemeClr val="lt1"/>
-              </a:fontRef>
-            </p:style>
-            <p:txBody>
-              <a:bodyPr rot="0" spcFirstLastPara="0" vertOverflow="overflow" horzOverflow="overflow" vert="horz" wrap="square" lIns="53996" tIns="26998" rIns="53996" bIns="26998" numCol="1" spcCol="0" rtlCol="0" fromWordArt="0" anchor="ctr" anchorCtr="0" forceAA="0" compatLnSpc="1">
-                <a:prstTxWarp prst="textNoShape">
-                  <a:avLst/>
-                </a:prstTxWarp>
-                <a:noAutofit/>
-              </a:bodyPr>
-              <a:lstStyle/>
-              <a:p>
-                <a:pPr algn="ctr"/>
-                <a:r>
-                  <a:rPr lang="en-US" dirty="0">
-                    <a:solidFill>
-                      <a:schemeClr val="tx1"/>
-                    </a:solidFill>
-                    <a:latin typeface="Times New Roman" panose="02020603050405020304" pitchFamily="18" charset="0"/>
-                    <a:cs typeface="Times New Roman" panose="02020603050405020304" pitchFamily="18" charset="0"/>
-                  </a:rPr>
-                  <a:t>D1</a:t>
-                </a:r>
-              </a:p>
-            </p:txBody>
-          </p:sp>
-          <p:sp>
-            <p:nvSpPr>
-              <p:cNvPr id="91" name="Oval 90">
-                <a:extLst>
-                  <a:ext uri="{FF2B5EF4-FFF2-40B4-BE49-F238E27FC236}">
-                    <a16:creationId xmlns:a16="http://schemas.microsoft.com/office/drawing/2014/main" id="{EDC4E5B4-422E-4761-8ABB-5ED3E84357EF}"/>
-                  </a:ext>
-                </a:extLst>
-              </p:cNvPr>
-              <p:cNvSpPr/>
-              <p:nvPr/>
-            </p:nvSpPr>
-            <p:spPr>
-              <a:xfrm>
-                <a:off x="3345649" y="2107653"/>
-                <a:ext cx="1634140" cy="1599952"/>
-              </a:xfrm>
-              <a:prstGeom prst="ellipse">
-                <a:avLst/>
-              </a:prstGeom>
-              <a:solidFill>
-                <a:schemeClr val="bg1"/>
-              </a:solidFill>
-              <a:ln w="19050">
+                <a:latin typeface="Times New Roman" panose="02020603050405020304" pitchFamily="18" charset="0"/>
+                <a:cs typeface="Times New Roman" panose="02020603050405020304" pitchFamily="18" charset="0"/>
+              </a:rPr>
+              <a:t>D1</a:t>
+            </a:r>
+          </a:p>
+        </p:txBody>
+      </p:sp>
+      <p:sp>
+        <p:nvSpPr>
+          <p:cNvPr id="91" name="Oval 90">
+            <a:extLst>
+              <a:ext uri="{FF2B5EF4-FFF2-40B4-BE49-F238E27FC236}">
+                <a16:creationId xmlns:a16="http://schemas.microsoft.com/office/drawing/2014/main" id="{EDC4E5B4-422E-4761-8ABB-5ED3E84357EF}"/>
+              </a:ext>
+            </a:extLst>
+          </p:cNvPr>
+          <p:cNvSpPr/>
+          <p:nvPr/>
+        </p:nvSpPr>
+        <p:spPr>
+          <a:xfrm>
+            <a:off x="1359560" y="850832"/>
+            <a:ext cx="1634140" cy="1599952"/>
+          </a:xfrm>
+          <a:prstGeom prst="ellipse">
+            <a:avLst/>
+          </a:prstGeom>
+          <a:solidFill>
+            <a:schemeClr val="bg1"/>
+          </a:solidFill>
+          <a:ln w="19050">
+            <a:solidFill>
+              <a:schemeClr val="tx1"/>
+            </a:solidFill>
+          </a:ln>
+        </p:spPr>
+        <p:style>
+          <a:lnRef idx="2">
+            <a:schemeClr val="accent1">
+              <a:shade val="50000"/>
+            </a:schemeClr>
+          </a:lnRef>
+          <a:fillRef idx="1">
+            <a:schemeClr val="accent1"/>
+          </a:fillRef>
+          <a:effectRef idx="0">
+            <a:schemeClr val="accent1"/>
+          </a:effectRef>
+          <a:fontRef idx="minor">
+            <a:schemeClr val="lt1"/>
+          </a:fontRef>
+        </p:style>
+        <p:txBody>
+          <a:bodyPr lIns="0" rIns="0" rtlCol="0" anchor="ctr"/>
+          <a:lstStyle/>
+          <a:p>
+            <a:pPr algn="ctr"/>
+            <a:r>
+              <a:rPr lang="en-US" dirty="0">
                 <a:solidFill>
                   <a:schemeClr val="tx1"/>
                 </a:solidFill>
-              </a:ln>
-            </p:spPr>
-            <p:style>
-              <a:lnRef idx="2">
-                <a:schemeClr val="accent1">
-                  <a:shade val="50000"/>
-                </a:schemeClr>
-              </a:lnRef>
-              <a:fillRef idx="1">
-                <a:schemeClr val="accent1"/>
-              </a:fillRef>
-              <a:effectRef idx="0">
-                <a:schemeClr val="accent1"/>
-              </a:effectRef>
-              <a:fontRef idx="minor">
-                <a:schemeClr val="lt1"/>
-              </a:fontRef>
-            </p:style>
-            <p:txBody>
-              <a:bodyPr lIns="0" rIns="0" rtlCol="0" anchor="ctr"/>
-              <a:lstStyle/>
-              <a:p>
-                <a:pPr algn="ctr"/>
-                <a:r>
-                  <a:rPr lang="en-US" dirty="0">
-                    <a:solidFill>
-                      <a:schemeClr val="tx1"/>
-                    </a:solidFill>
-                    <a:latin typeface="Times New Roman" panose="02020603050405020304" pitchFamily="18" charset="0"/>
-                    <a:cs typeface="Times New Roman" panose="02020603050405020304" pitchFamily="18" charset="0"/>
-                  </a:rPr>
-                  <a:t>Disillusion</a:t>
-                </a:r>
-              </a:p>
-            </p:txBody>
-          </p:sp>
-          <p:cxnSp>
-            <p:nvCxnSpPr>
-              <p:cNvPr id="92" name="Straight Arrow Connector 91">
-                <a:extLst>
-                  <a:ext uri="{FF2B5EF4-FFF2-40B4-BE49-F238E27FC236}">
-                    <a16:creationId xmlns:a16="http://schemas.microsoft.com/office/drawing/2014/main" id="{A0171EDF-6F98-4773-A690-45B98A5726EB}"/>
-                  </a:ext>
-                </a:extLst>
-              </p:cNvPr>
-              <p:cNvCxnSpPr>
-                <a:cxnSpLocks/>
-                <a:stCxn id="91" idx="4"/>
-                <a:endCxn id="88" idx="0"/>
-              </p:cNvCxnSpPr>
-              <p:nvPr/>
-            </p:nvCxnSpPr>
-            <p:spPr>
-              <a:xfrm flipH="1">
-                <a:off x="3097159" y="3707605"/>
-                <a:ext cx="1065560" cy="942391"/>
-              </a:xfrm>
-              <a:prstGeom prst="straightConnector1">
-                <a:avLst/>
-              </a:prstGeom>
-              <a:ln w="19050">
+                <a:latin typeface="Times New Roman" panose="02020603050405020304" pitchFamily="18" charset="0"/>
+                <a:cs typeface="Times New Roman" panose="02020603050405020304" pitchFamily="18" charset="0"/>
+              </a:rPr>
+              <a:t>Disillusion</a:t>
+            </a:r>
+          </a:p>
+        </p:txBody>
+      </p:sp>
+      <p:cxnSp>
+        <p:nvCxnSpPr>
+          <p:cNvPr id="92" name="Straight Arrow Connector 91">
+            <a:extLst>
+              <a:ext uri="{FF2B5EF4-FFF2-40B4-BE49-F238E27FC236}">
+                <a16:creationId xmlns:a16="http://schemas.microsoft.com/office/drawing/2014/main" id="{A0171EDF-6F98-4773-A690-45B98A5726EB}"/>
+              </a:ext>
+            </a:extLst>
+          </p:cNvPr>
+          <p:cNvCxnSpPr>
+            <a:cxnSpLocks/>
+            <a:stCxn id="91" idx="4"/>
+            <a:endCxn id="88" idx="0"/>
+          </p:cNvCxnSpPr>
+          <p:nvPr/>
+        </p:nvCxnSpPr>
+        <p:spPr>
+          <a:xfrm flipH="1">
+            <a:off x="1111070" y="2450784"/>
+            <a:ext cx="1065560" cy="942391"/>
+          </a:xfrm>
+          <a:prstGeom prst="straightConnector1">
+            <a:avLst/>
+          </a:prstGeom>
+          <a:ln w="19050">
+            <a:solidFill>
+              <a:schemeClr val="tx1"/>
+            </a:solidFill>
+            <a:tailEnd type="triangle"/>
+          </a:ln>
+        </p:spPr>
+        <p:style>
+          <a:lnRef idx="1">
+            <a:schemeClr val="accent1"/>
+          </a:lnRef>
+          <a:fillRef idx="0">
+            <a:schemeClr val="accent1"/>
+          </a:fillRef>
+          <a:effectRef idx="0">
+            <a:schemeClr val="accent1"/>
+          </a:effectRef>
+          <a:fontRef idx="minor">
+            <a:schemeClr val="tx1"/>
+          </a:fontRef>
+        </p:style>
+      </p:cxnSp>
+      <p:sp>
+        <p:nvSpPr>
+          <p:cNvPr id="95" name="Oval 94">
+            <a:extLst>
+              <a:ext uri="{FF2B5EF4-FFF2-40B4-BE49-F238E27FC236}">
+                <a16:creationId xmlns:a16="http://schemas.microsoft.com/office/drawing/2014/main" id="{35EA1314-289C-4D2F-8F74-3E6BB0DC24DE}"/>
+              </a:ext>
+            </a:extLst>
+          </p:cNvPr>
+          <p:cNvSpPr>
+            <a:spLocks noChangeAspect="1"/>
+          </p:cNvSpPr>
+          <p:nvPr/>
+        </p:nvSpPr>
+        <p:spPr>
+          <a:xfrm>
+            <a:off x="770623" y="4416647"/>
+            <a:ext cx="680891" cy="666648"/>
+          </a:xfrm>
+          <a:prstGeom prst="ellipse">
+            <a:avLst/>
+          </a:prstGeom>
+          <a:solidFill>
+            <a:schemeClr val="bg1"/>
+          </a:solidFill>
+          <a:ln w="19050">
+            <a:solidFill>
+              <a:schemeClr val="tx1"/>
+            </a:solidFill>
+          </a:ln>
+        </p:spPr>
+        <p:style>
+          <a:lnRef idx="2">
+            <a:schemeClr val="accent1">
+              <a:shade val="50000"/>
+            </a:schemeClr>
+          </a:lnRef>
+          <a:fillRef idx="1">
+            <a:schemeClr val="accent1"/>
+          </a:fillRef>
+          <a:effectRef idx="0">
+            <a:schemeClr val="accent1"/>
+          </a:effectRef>
+          <a:fontRef idx="minor">
+            <a:schemeClr val="lt1"/>
+          </a:fontRef>
+        </p:style>
+        <p:txBody>
+          <a:bodyPr rtlCol="0" anchor="ctr"/>
+          <a:lstStyle/>
+          <a:p>
+            <a:pPr algn="ctr"/>
+            <a:r>
+              <a:rPr lang="en-US" sz="1600" dirty="0">
                 <a:solidFill>
                   <a:schemeClr val="tx1"/>
                 </a:solidFill>
-                <a:tailEnd type="triangle"/>
-              </a:ln>
-            </p:spPr>
-            <p:style>
-              <a:lnRef idx="1">
-                <a:schemeClr val="accent1"/>
-              </a:lnRef>
-              <a:fillRef idx="0">
-                <a:schemeClr val="accent1"/>
-              </a:fillRef>
-              <a:effectRef idx="0">
-                <a:schemeClr val="accent1"/>
-              </a:effectRef>
-              <a:fontRef idx="minor">
-                <a:schemeClr val="tx1"/>
-              </a:fontRef>
-            </p:style>
-          </p:cxnSp>
-          <p:sp>
-            <p:nvSpPr>
-              <p:cNvPr id="95" name="Oval 94">
-                <a:extLst>
-                  <a:ext uri="{FF2B5EF4-FFF2-40B4-BE49-F238E27FC236}">
-                    <a16:creationId xmlns:a16="http://schemas.microsoft.com/office/drawing/2014/main" id="{35EA1314-289C-4D2F-8F74-3E6BB0DC24DE}"/>
-                  </a:ext>
-                </a:extLst>
-              </p:cNvPr>
-              <p:cNvSpPr>
-                <a:spLocks noChangeAspect="1"/>
-              </p:cNvSpPr>
-              <p:nvPr/>
-            </p:nvSpPr>
-            <p:spPr>
-              <a:xfrm>
-                <a:off x="2756712" y="5673468"/>
-                <a:ext cx="680891" cy="666648"/>
-              </a:xfrm>
-              <a:prstGeom prst="ellipse">
-                <a:avLst/>
-              </a:prstGeom>
-              <a:solidFill>
-                <a:schemeClr val="bg1"/>
-              </a:solidFill>
-              <a:ln w="19050">
+                <a:latin typeface="Times New Roman" panose="02020603050405020304" pitchFamily="18" charset="0"/>
+                <a:cs typeface="Times New Roman" panose="02020603050405020304" pitchFamily="18" charset="0"/>
+              </a:rPr>
+              <a:t>u</a:t>
+            </a:r>
+            <a:r>
+              <a:rPr lang="en-US" sz="1600" baseline="-25000" dirty="0">
                 <a:solidFill>
                   <a:schemeClr val="tx1"/>
                 </a:solidFill>
-              </a:ln>
-            </p:spPr>
-            <p:style>
-              <a:lnRef idx="2">
-                <a:schemeClr val="accent1">
-                  <a:shade val="50000"/>
-                </a:schemeClr>
-              </a:lnRef>
-              <a:fillRef idx="1">
-                <a:schemeClr val="accent1"/>
-              </a:fillRef>
-              <a:effectRef idx="0">
-                <a:schemeClr val="accent1"/>
-              </a:effectRef>
-              <a:fontRef idx="minor">
-                <a:schemeClr val="lt1"/>
-              </a:fontRef>
-            </p:style>
-            <p:txBody>
-              <a:bodyPr rtlCol="0" anchor="ctr"/>
-              <a:lstStyle/>
-              <a:p>
-                <a:pPr algn="ctr"/>
-                <a:r>
-                  <a:rPr lang="en-US" sz="1600" dirty="0">
-                    <a:solidFill>
-                      <a:schemeClr val="tx1"/>
-                    </a:solidFill>
-                    <a:latin typeface="Times New Roman" panose="02020603050405020304" pitchFamily="18" charset="0"/>
-                    <a:cs typeface="Times New Roman" panose="02020603050405020304" pitchFamily="18" charset="0"/>
-                  </a:rPr>
-                  <a:t>u</a:t>
-                </a:r>
-                <a:r>
-                  <a:rPr lang="en-US" sz="1600" baseline="-25000" dirty="0">
-                    <a:solidFill>
-                      <a:schemeClr val="tx1"/>
-                    </a:solidFill>
-                    <a:latin typeface="Times New Roman" panose="02020603050405020304" pitchFamily="18" charset="0"/>
-                    <a:cs typeface="Times New Roman" panose="02020603050405020304" pitchFamily="18" charset="0"/>
-                  </a:rPr>
-                  <a:t>D1</a:t>
-                </a:r>
-                <a:endParaRPr lang="en-US" sz="1600" dirty="0">
-                  <a:solidFill>
-                    <a:schemeClr val="tx1"/>
-                  </a:solidFill>
-                  <a:latin typeface="Times New Roman" panose="02020603050405020304" pitchFamily="18" charset="0"/>
-                  <a:cs typeface="Times New Roman" panose="02020603050405020304" pitchFamily="18" charset="0"/>
-                </a:endParaRPr>
-              </a:p>
-            </p:txBody>
-          </p:sp>
-          <p:cxnSp>
-            <p:nvCxnSpPr>
-              <p:cNvPr id="102" name="Straight Arrow Connector 101">
-                <a:extLst>
-                  <a:ext uri="{FF2B5EF4-FFF2-40B4-BE49-F238E27FC236}">
-                    <a16:creationId xmlns:a16="http://schemas.microsoft.com/office/drawing/2014/main" id="{472D759D-5652-407E-A1EB-EE29B8B90E81}"/>
-                  </a:ext>
-                </a:extLst>
-              </p:cNvPr>
-              <p:cNvCxnSpPr>
-                <a:cxnSpLocks/>
-                <a:stCxn id="88" idx="2"/>
-                <a:endCxn id="95" idx="0"/>
-              </p:cNvCxnSpPr>
-              <p:nvPr/>
-            </p:nvCxnSpPr>
-            <p:spPr>
-              <a:xfrm flipH="1">
-                <a:off x="3097158" y="5399881"/>
-                <a:ext cx="1" cy="273587"/>
-              </a:xfrm>
-              <a:prstGeom prst="straightConnector1">
-                <a:avLst/>
-              </a:prstGeom>
-              <a:ln w="19050">
-                <a:solidFill>
-                  <a:schemeClr val="tx1"/>
-                </a:solidFill>
-                <a:tailEnd type="triangle"/>
-              </a:ln>
-            </p:spPr>
-            <p:style>
-              <a:lnRef idx="1">
-                <a:schemeClr val="accent1"/>
-              </a:lnRef>
-              <a:fillRef idx="0">
-                <a:schemeClr val="accent1"/>
-              </a:fillRef>
-              <a:effectRef idx="0">
-                <a:schemeClr val="accent1"/>
-              </a:effectRef>
-              <a:fontRef idx="minor">
-                <a:schemeClr val="tx1"/>
-              </a:fontRef>
-            </p:style>
-          </p:cxnSp>
-          <p:sp>
-            <p:nvSpPr>
-              <p:cNvPr id="16" name="Rectangle 15">
-                <a:extLst>
-                  <a:ext uri="{FF2B5EF4-FFF2-40B4-BE49-F238E27FC236}">
-                    <a16:creationId xmlns:a16="http://schemas.microsoft.com/office/drawing/2014/main" id="{EDA56541-603C-6B23-A371-DC00A83D968B}"/>
-                  </a:ext>
-                </a:extLst>
-              </p:cNvPr>
-              <p:cNvSpPr/>
-              <p:nvPr/>
-            </p:nvSpPr>
-            <p:spPr>
-              <a:xfrm>
-                <a:off x="3779766" y="4649996"/>
-                <a:ext cx="765907" cy="749885"/>
-              </a:xfrm>
-              <a:prstGeom prst="rect">
-                <a:avLst/>
-              </a:prstGeom>
-              <a:solidFill>
-                <a:schemeClr val="bg1"/>
-              </a:solidFill>
-              <a:ln w="19050">
-                <a:solidFill>
-                  <a:schemeClr val="tx1"/>
-                </a:solidFill>
-              </a:ln>
-            </p:spPr>
-            <p:style>
-              <a:lnRef idx="2">
-                <a:schemeClr val="accent1">
-                  <a:shade val="50000"/>
-                </a:schemeClr>
-              </a:lnRef>
-              <a:fillRef idx="1">
-                <a:schemeClr val="accent1"/>
-              </a:fillRef>
-              <a:effectRef idx="0">
-                <a:schemeClr val="accent1"/>
-              </a:effectRef>
-              <a:fontRef idx="minor">
-                <a:schemeClr val="lt1"/>
-              </a:fontRef>
-            </p:style>
-            <p:txBody>
-              <a:bodyPr rot="0" spcFirstLastPara="0" vertOverflow="overflow" horzOverflow="overflow" vert="horz" wrap="square" lIns="53996" tIns="26998" rIns="53996" bIns="26998" numCol="1" spcCol="0" rtlCol="0" fromWordArt="0" anchor="ctr" anchorCtr="0" forceAA="0" compatLnSpc="1">
-                <a:prstTxWarp prst="textNoShape">
-                  <a:avLst/>
-                </a:prstTxWarp>
-                <a:noAutofit/>
-              </a:bodyPr>
-              <a:lstStyle/>
-              <a:p>
-                <a:pPr algn="ctr"/>
-                <a:r>
-                  <a:rPr lang="en-US" dirty="0">
-                    <a:solidFill>
-                      <a:schemeClr val="tx1"/>
-                    </a:solidFill>
-                    <a:latin typeface="Times New Roman" panose="02020603050405020304" pitchFamily="18" charset="0"/>
-                    <a:cs typeface="Times New Roman" panose="02020603050405020304" pitchFamily="18" charset="0"/>
-                  </a:rPr>
-                  <a:t>D2</a:t>
-                </a:r>
-              </a:p>
-            </p:txBody>
-          </p:sp>
-          <p:sp>
-            <p:nvSpPr>
-              <p:cNvPr id="17" name="Oval 16">
-                <a:extLst>
-                  <a:ext uri="{FF2B5EF4-FFF2-40B4-BE49-F238E27FC236}">
-                    <a16:creationId xmlns:a16="http://schemas.microsoft.com/office/drawing/2014/main" id="{837E9B68-BEBC-4E75-B415-B1098982A1E9}"/>
-                  </a:ext>
-                </a:extLst>
-              </p:cNvPr>
-              <p:cNvSpPr>
-                <a:spLocks noChangeAspect="1"/>
-              </p:cNvSpPr>
-              <p:nvPr/>
-            </p:nvSpPr>
-            <p:spPr>
-              <a:xfrm>
-                <a:off x="3822273" y="5673468"/>
-                <a:ext cx="680891" cy="666648"/>
-              </a:xfrm>
-              <a:prstGeom prst="ellipse">
-                <a:avLst/>
-              </a:prstGeom>
-              <a:solidFill>
-                <a:schemeClr val="bg1"/>
-              </a:solidFill>
-              <a:ln w="19050">
-                <a:solidFill>
-                  <a:schemeClr val="tx1"/>
-                </a:solidFill>
-              </a:ln>
-            </p:spPr>
-            <p:style>
-              <a:lnRef idx="2">
-                <a:schemeClr val="accent1">
-                  <a:shade val="50000"/>
-                </a:schemeClr>
-              </a:lnRef>
-              <a:fillRef idx="1">
-                <a:schemeClr val="accent1"/>
-              </a:fillRef>
-              <a:effectRef idx="0">
-                <a:schemeClr val="accent1"/>
-              </a:effectRef>
-              <a:fontRef idx="minor">
-                <a:schemeClr val="lt1"/>
-              </a:fontRef>
-            </p:style>
-            <p:txBody>
-              <a:bodyPr rtlCol="0" anchor="ctr"/>
-              <a:lstStyle/>
-              <a:p>
-                <a:pPr algn="ctr"/>
-                <a:r>
-                  <a:rPr lang="en-US" sz="1600" dirty="0">
-                    <a:solidFill>
-                      <a:schemeClr val="tx1"/>
-                    </a:solidFill>
-                    <a:latin typeface="Times New Roman" panose="02020603050405020304" pitchFamily="18" charset="0"/>
-                    <a:cs typeface="Times New Roman" panose="02020603050405020304" pitchFamily="18" charset="0"/>
-                  </a:rPr>
-                  <a:t>u</a:t>
-                </a:r>
-                <a:r>
-                  <a:rPr lang="en-US" sz="1600" baseline="-25000" dirty="0">
-                    <a:solidFill>
-                      <a:schemeClr val="tx1"/>
-                    </a:solidFill>
-                    <a:latin typeface="Times New Roman" panose="02020603050405020304" pitchFamily="18" charset="0"/>
-                    <a:cs typeface="Times New Roman" panose="02020603050405020304" pitchFamily="18" charset="0"/>
-                  </a:rPr>
-                  <a:t>D2</a:t>
-                </a:r>
-                <a:endParaRPr lang="en-US" sz="1600" dirty="0">
-                  <a:solidFill>
-                    <a:schemeClr val="tx1"/>
-                  </a:solidFill>
-                  <a:latin typeface="Times New Roman" panose="02020603050405020304" pitchFamily="18" charset="0"/>
-                  <a:cs typeface="Times New Roman" panose="02020603050405020304" pitchFamily="18" charset="0"/>
-                </a:endParaRPr>
-              </a:p>
-            </p:txBody>
-          </p:sp>
-          <p:cxnSp>
-            <p:nvCxnSpPr>
-              <p:cNvPr id="18" name="Straight Arrow Connector 17">
-                <a:extLst>
-                  <a:ext uri="{FF2B5EF4-FFF2-40B4-BE49-F238E27FC236}">
-                    <a16:creationId xmlns:a16="http://schemas.microsoft.com/office/drawing/2014/main" id="{105218F0-7F56-F926-5A55-C3AB3D2DD1BD}"/>
-                  </a:ext>
-                </a:extLst>
-              </p:cNvPr>
-              <p:cNvCxnSpPr>
-                <a:cxnSpLocks/>
-                <a:stCxn id="16" idx="2"/>
-                <a:endCxn id="17" idx="0"/>
-              </p:cNvCxnSpPr>
-              <p:nvPr/>
-            </p:nvCxnSpPr>
-            <p:spPr>
-              <a:xfrm flipH="1">
-                <a:off x="4162719" y="5399881"/>
-                <a:ext cx="1" cy="273587"/>
-              </a:xfrm>
-              <a:prstGeom prst="straightConnector1">
-                <a:avLst/>
-              </a:prstGeom>
-              <a:ln w="19050">
-                <a:solidFill>
-                  <a:schemeClr val="tx1"/>
-                </a:solidFill>
-                <a:tailEnd type="triangle"/>
-              </a:ln>
-            </p:spPr>
-            <p:style>
-              <a:lnRef idx="1">
-                <a:schemeClr val="accent1"/>
-              </a:lnRef>
-              <a:fillRef idx="0">
-                <a:schemeClr val="accent1"/>
-              </a:fillRef>
-              <a:effectRef idx="0">
-                <a:schemeClr val="accent1"/>
-              </a:effectRef>
-              <a:fontRef idx="minor">
-                <a:schemeClr val="tx1"/>
-              </a:fontRef>
-            </p:style>
-          </p:cxnSp>
-          <p:sp>
-            <p:nvSpPr>
-              <p:cNvPr id="19" name="Rectangle 18">
-                <a:extLst>
-                  <a:ext uri="{FF2B5EF4-FFF2-40B4-BE49-F238E27FC236}">
-                    <a16:creationId xmlns:a16="http://schemas.microsoft.com/office/drawing/2014/main" id="{1A48AECE-5FB0-1E8D-749F-F8287A9BB2DA}"/>
-                  </a:ext>
-                </a:extLst>
-              </p:cNvPr>
-              <p:cNvSpPr/>
-              <p:nvPr/>
-            </p:nvSpPr>
-            <p:spPr>
-              <a:xfrm>
-                <a:off x="4845325" y="4649995"/>
-                <a:ext cx="765907" cy="749885"/>
-              </a:xfrm>
-              <a:prstGeom prst="rect">
-                <a:avLst/>
-              </a:prstGeom>
-              <a:solidFill>
-                <a:schemeClr val="bg1"/>
-              </a:solidFill>
-              <a:ln w="19050">
-                <a:solidFill>
-                  <a:schemeClr val="tx1"/>
-                </a:solidFill>
-              </a:ln>
-            </p:spPr>
-            <p:style>
-              <a:lnRef idx="2">
-                <a:schemeClr val="accent1">
-                  <a:shade val="50000"/>
-                </a:schemeClr>
-              </a:lnRef>
-              <a:fillRef idx="1">
-                <a:schemeClr val="accent1"/>
-              </a:fillRef>
-              <a:effectRef idx="0">
-                <a:schemeClr val="accent1"/>
-              </a:effectRef>
-              <a:fontRef idx="minor">
-                <a:schemeClr val="lt1"/>
-              </a:fontRef>
-            </p:style>
-            <p:txBody>
-              <a:bodyPr rot="0" spcFirstLastPara="0" vertOverflow="overflow" horzOverflow="overflow" vert="horz" wrap="square" lIns="53996" tIns="26998" rIns="53996" bIns="26998" numCol="1" spcCol="0" rtlCol="0" fromWordArt="0" anchor="ctr" anchorCtr="0" forceAA="0" compatLnSpc="1">
-                <a:prstTxWarp prst="textNoShape">
-                  <a:avLst/>
-                </a:prstTxWarp>
-                <a:noAutofit/>
-              </a:bodyPr>
-              <a:lstStyle/>
-              <a:p>
-                <a:pPr algn="ctr"/>
-                <a:r>
-                  <a:rPr lang="en-US" dirty="0">
-                    <a:solidFill>
-                      <a:schemeClr val="tx1"/>
-                    </a:solidFill>
-                    <a:latin typeface="Times New Roman" panose="02020603050405020304" pitchFamily="18" charset="0"/>
-                    <a:cs typeface="Times New Roman" panose="02020603050405020304" pitchFamily="18" charset="0"/>
-                  </a:rPr>
-                  <a:t>D3</a:t>
-                </a:r>
-              </a:p>
-            </p:txBody>
-          </p:sp>
-          <p:sp>
-            <p:nvSpPr>
-              <p:cNvPr id="20" name="Oval 19">
-                <a:extLst>
-                  <a:ext uri="{FF2B5EF4-FFF2-40B4-BE49-F238E27FC236}">
-                    <a16:creationId xmlns:a16="http://schemas.microsoft.com/office/drawing/2014/main" id="{3BB0E90F-47F7-4BD2-E020-29262840F82A}"/>
-                  </a:ext>
-                </a:extLst>
-              </p:cNvPr>
-              <p:cNvSpPr>
-                <a:spLocks noChangeAspect="1"/>
-              </p:cNvSpPr>
-              <p:nvPr/>
-            </p:nvSpPr>
-            <p:spPr>
-              <a:xfrm>
-                <a:off x="4886117" y="5673468"/>
-                <a:ext cx="680891" cy="666648"/>
-              </a:xfrm>
-              <a:prstGeom prst="ellipse">
-                <a:avLst/>
-              </a:prstGeom>
-              <a:solidFill>
-                <a:schemeClr val="bg1"/>
-              </a:solidFill>
-              <a:ln w="19050">
-                <a:solidFill>
-                  <a:schemeClr val="tx1"/>
-                </a:solidFill>
-              </a:ln>
-            </p:spPr>
-            <p:style>
-              <a:lnRef idx="2">
-                <a:schemeClr val="accent1">
-                  <a:shade val="50000"/>
-                </a:schemeClr>
-              </a:lnRef>
-              <a:fillRef idx="1">
-                <a:schemeClr val="accent1"/>
-              </a:fillRef>
-              <a:effectRef idx="0">
-                <a:schemeClr val="accent1"/>
-              </a:effectRef>
-              <a:fontRef idx="minor">
-                <a:schemeClr val="lt1"/>
-              </a:fontRef>
-            </p:style>
-            <p:txBody>
-              <a:bodyPr rtlCol="0" anchor="ctr"/>
-              <a:lstStyle/>
-              <a:p>
-                <a:pPr algn="ctr"/>
-                <a:r>
-                  <a:rPr lang="en-US" sz="1600" dirty="0">
-                    <a:solidFill>
-                      <a:schemeClr val="tx1"/>
-                    </a:solidFill>
-                    <a:latin typeface="Times New Roman" panose="02020603050405020304" pitchFamily="18" charset="0"/>
-                    <a:cs typeface="Times New Roman" panose="02020603050405020304" pitchFamily="18" charset="0"/>
-                  </a:rPr>
-                  <a:t>u</a:t>
-                </a:r>
-                <a:r>
-                  <a:rPr lang="en-US" sz="1600" baseline="-25000" dirty="0">
-                    <a:solidFill>
-                      <a:schemeClr val="tx1"/>
-                    </a:solidFill>
-                    <a:latin typeface="Times New Roman" panose="02020603050405020304" pitchFamily="18" charset="0"/>
-                    <a:cs typeface="Times New Roman" panose="02020603050405020304" pitchFamily="18" charset="0"/>
-                  </a:rPr>
-                  <a:t>D3</a:t>
-                </a:r>
-                <a:endParaRPr lang="en-US" sz="1600" dirty="0">
-                  <a:solidFill>
-                    <a:schemeClr val="tx1"/>
-                  </a:solidFill>
-                  <a:latin typeface="Times New Roman" panose="02020603050405020304" pitchFamily="18" charset="0"/>
-                  <a:cs typeface="Times New Roman" panose="02020603050405020304" pitchFamily="18" charset="0"/>
-                </a:endParaRPr>
-              </a:p>
-            </p:txBody>
-          </p:sp>
-          <p:cxnSp>
-            <p:nvCxnSpPr>
-              <p:cNvPr id="21" name="Straight Arrow Connector 20">
-                <a:extLst>
-                  <a:ext uri="{FF2B5EF4-FFF2-40B4-BE49-F238E27FC236}">
-                    <a16:creationId xmlns:a16="http://schemas.microsoft.com/office/drawing/2014/main" id="{3FB46C63-8D55-ABC1-3571-4AC1E9E97745}"/>
-                  </a:ext>
-                </a:extLst>
-              </p:cNvPr>
-              <p:cNvCxnSpPr>
-                <a:cxnSpLocks/>
-                <a:stCxn id="19" idx="2"/>
-                <a:endCxn id="20" idx="0"/>
-              </p:cNvCxnSpPr>
-              <p:nvPr/>
-            </p:nvCxnSpPr>
-            <p:spPr>
-              <a:xfrm flipH="1">
-                <a:off x="5226563" y="5399880"/>
-                <a:ext cx="1716" cy="273588"/>
-              </a:xfrm>
-              <a:prstGeom prst="straightConnector1">
-                <a:avLst/>
-              </a:prstGeom>
-              <a:ln w="19050">
-                <a:solidFill>
-                  <a:schemeClr val="tx1"/>
-                </a:solidFill>
-                <a:tailEnd type="triangle"/>
-              </a:ln>
-            </p:spPr>
-            <p:style>
-              <a:lnRef idx="1">
-                <a:schemeClr val="accent1"/>
-              </a:lnRef>
-              <a:fillRef idx="0">
-                <a:schemeClr val="accent1"/>
-              </a:fillRef>
-              <a:effectRef idx="0">
-                <a:schemeClr val="accent1"/>
-              </a:effectRef>
-              <a:fontRef idx="minor">
-                <a:schemeClr val="tx1"/>
-              </a:fontRef>
-            </p:style>
-          </p:cxnSp>
-          <p:cxnSp>
-            <p:nvCxnSpPr>
-              <p:cNvPr id="23" name="Straight Arrow Connector 22">
-                <a:extLst>
-                  <a:ext uri="{FF2B5EF4-FFF2-40B4-BE49-F238E27FC236}">
-                    <a16:creationId xmlns:a16="http://schemas.microsoft.com/office/drawing/2014/main" id="{A552E9A0-752B-3E8D-11C7-7C26B05B1EDF}"/>
-                  </a:ext>
-                </a:extLst>
-              </p:cNvPr>
-              <p:cNvCxnSpPr>
-                <a:cxnSpLocks/>
-                <a:stCxn id="91" idx="4"/>
-                <a:endCxn id="16" idx="0"/>
-              </p:cNvCxnSpPr>
-              <p:nvPr/>
-            </p:nvCxnSpPr>
-            <p:spPr>
-              <a:xfrm>
-                <a:off x="4162719" y="3707605"/>
-                <a:ext cx="1" cy="942391"/>
-              </a:xfrm>
-              <a:prstGeom prst="straightConnector1">
-                <a:avLst/>
-              </a:prstGeom>
-              <a:ln w="19050">
-                <a:solidFill>
-                  <a:schemeClr val="tx1"/>
-                </a:solidFill>
-                <a:tailEnd type="triangle"/>
-              </a:ln>
-            </p:spPr>
-            <p:style>
-              <a:lnRef idx="1">
-                <a:schemeClr val="accent1"/>
-              </a:lnRef>
-              <a:fillRef idx="0">
-                <a:schemeClr val="accent1"/>
-              </a:fillRef>
-              <a:effectRef idx="0">
-                <a:schemeClr val="accent1"/>
-              </a:effectRef>
-              <a:fontRef idx="minor">
-                <a:schemeClr val="tx1"/>
-              </a:fontRef>
-            </p:style>
-          </p:cxnSp>
-          <p:cxnSp>
-            <p:nvCxnSpPr>
-              <p:cNvPr id="24" name="Straight Arrow Connector 23">
-                <a:extLst>
-                  <a:ext uri="{FF2B5EF4-FFF2-40B4-BE49-F238E27FC236}">
-                    <a16:creationId xmlns:a16="http://schemas.microsoft.com/office/drawing/2014/main" id="{616D0402-49C2-8E52-97AB-3F476E2F5DD4}"/>
-                  </a:ext>
-                </a:extLst>
-              </p:cNvPr>
-              <p:cNvCxnSpPr>
-                <a:cxnSpLocks/>
-                <a:stCxn id="91" idx="4"/>
-                <a:endCxn id="19" idx="0"/>
-              </p:cNvCxnSpPr>
-              <p:nvPr/>
-            </p:nvCxnSpPr>
-            <p:spPr>
-              <a:xfrm>
-                <a:off x="4162719" y="3707605"/>
-                <a:ext cx="1065560" cy="942390"/>
-              </a:xfrm>
-              <a:prstGeom prst="straightConnector1">
-                <a:avLst/>
-              </a:prstGeom>
-              <a:ln w="19050">
-                <a:solidFill>
-                  <a:schemeClr val="tx1"/>
-                </a:solidFill>
-                <a:tailEnd type="triangle"/>
-              </a:ln>
-            </p:spPr>
-            <p:style>
-              <a:lnRef idx="1">
-                <a:schemeClr val="accent1"/>
-              </a:lnRef>
-              <a:fillRef idx="0">
-                <a:schemeClr val="accent1"/>
-              </a:fillRef>
-              <a:effectRef idx="0">
-                <a:schemeClr val="accent1"/>
-              </a:effectRef>
-              <a:fontRef idx="minor">
-                <a:schemeClr val="tx1"/>
-              </a:fontRef>
-            </p:style>
-          </p:cxnSp>
-        </p:grpSp>
-        <p:grpSp>
-          <p:nvGrpSpPr>
-            <p:cNvPr id="113" name="Group 112">
-              <a:extLst>
-                <a:ext uri="{FF2B5EF4-FFF2-40B4-BE49-F238E27FC236}">
-                  <a16:creationId xmlns:a16="http://schemas.microsoft.com/office/drawing/2014/main" id="{E5C6392C-847C-68B4-0147-41F67848EEAE}"/>
-                </a:ext>
-              </a:extLst>
-            </p:cNvPr>
-            <p:cNvGrpSpPr/>
-            <p:nvPr/>
-          </p:nvGrpSpPr>
-          <p:grpSpPr>
-            <a:xfrm>
-              <a:off x="4873567" y="850832"/>
-              <a:ext cx="3355351" cy="4232463"/>
-              <a:chOff x="6022388" y="2107653"/>
-              <a:chExt cx="3355351" cy="4232463"/>
-            </a:xfrm>
-          </p:grpSpPr>
-          <p:sp>
-            <p:nvSpPr>
-              <p:cNvPr id="42" name="Rectangle 41">
-                <a:extLst>
-                  <a:ext uri="{FF2B5EF4-FFF2-40B4-BE49-F238E27FC236}">
-                    <a16:creationId xmlns:a16="http://schemas.microsoft.com/office/drawing/2014/main" id="{06695606-0BC6-8CFA-F6B2-4C1D8593FA58}"/>
-                  </a:ext>
-                </a:extLst>
-              </p:cNvPr>
-              <p:cNvSpPr/>
-              <p:nvPr/>
-            </p:nvSpPr>
-            <p:spPr>
-              <a:xfrm>
-                <a:off x="6885536" y="4649994"/>
-                <a:ext cx="765907" cy="749885"/>
-              </a:xfrm>
-              <a:prstGeom prst="rect">
-                <a:avLst/>
-              </a:prstGeom>
-              <a:solidFill>
-                <a:schemeClr val="bg1"/>
-              </a:solidFill>
-              <a:ln w="19050">
-                <a:solidFill>
-                  <a:schemeClr val="tx1"/>
-                </a:solidFill>
-              </a:ln>
-            </p:spPr>
-            <p:style>
-              <a:lnRef idx="2">
-                <a:schemeClr val="accent1">
-                  <a:shade val="50000"/>
-                </a:schemeClr>
-              </a:lnRef>
-              <a:fillRef idx="1">
-                <a:schemeClr val="accent1"/>
-              </a:fillRef>
-              <a:effectRef idx="0">
-                <a:schemeClr val="accent1"/>
-              </a:effectRef>
-              <a:fontRef idx="minor">
-                <a:schemeClr val="lt1"/>
-              </a:fontRef>
-            </p:style>
-            <p:txBody>
-              <a:bodyPr rot="0" spcFirstLastPara="0" vertOverflow="overflow" horzOverflow="overflow" vert="horz" wrap="square" lIns="53996" tIns="26998" rIns="53996" bIns="26998" numCol="1" spcCol="0" rtlCol="0" fromWordArt="0" anchor="ctr" anchorCtr="0" forceAA="0" compatLnSpc="1">
-                <a:prstTxWarp prst="textNoShape">
-                  <a:avLst/>
-                </a:prstTxWarp>
-                <a:noAutofit/>
-              </a:bodyPr>
-              <a:lstStyle/>
-              <a:p>
-                <a:pPr algn="ctr"/>
-                <a:r>
-                  <a:rPr lang="en-US" dirty="0">
-                    <a:solidFill>
-                      <a:schemeClr val="tx1"/>
-                    </a:solidFill>
-                    <a:latin typeface="Times New Roman" panose="02020603050405020304" pitchFamily="18" charset="0"/>
-                    <a:cs typeface="Times New Roman" panose="02020603050405020304" pitchFamily="18" charset="0"/>
-                  </a:rPr>
-                  <a:t>S2</a:t>
-                </a:r>
-              </a:p>
-            </p:txBody>
-          </p:sp>
-          <p:sp>
-            <p:nvSpPr>
-              <p:cNvPr id="43" name="Oval 42">
-                <a:extLst>
-                  <a:ext uri="{FF2B5EF4-FFF2-40B4-BE49-F238E27FC236}">
-                    <a16:creationId xmlns:a16="http://schemas.microsoft.com/office/drawing/2014/main" id="{380BBA56-8402-9591-70AB-9E4CD467E110}"/>
-                  </a:ext>
-                </a:extLst>
-              </p:cNvPr>
-              <p:cNvSpPr/>
-              <p:nvPr/>
-            </p:nvSpPr>
-            <p:spPr>
-              <a:xfrm>
-                <a:off x="6885536" y="2107653"/>
-                <a:ext cx="1634140" cy="1599952"/>
-              </a:xfrm>
-              <a:prstGeom prst="ellipse">
-                <a:avLst/>
-              </a:prstGeom>
-              <a:solidFill>
-                <a:schemeClr val="bg1"/>
-              </a:solidFill>
-              <a:ln w="19050">
-                <a:solidFill>
-                  <a:schemeClr val="tx1"/>
-                </a:solidFill>
-              </a:ln>
-            </p:spPr>
-            <p:style>
-              <a:lnRef idx="2">
-                <a:schemeClr val="accent1">
-                  <a:shade val="50000"/>
-                </a:schemeClr>
-              </a:lnRef>
-              <a:fillRef idx="1">
-                <a:schemeClr val="accent1"/>
-              </a:fillRef>
-              <a:effectRef idx="0">
-                <a:schemeClr val="accent1"/>
-              </a:effectRef>
-              <a:fontRef idx="minor">
-                <a:schemeClr val="lt1"/>
-              </a:fontRef>
-            </p:style>
-            <p:txBody>
-              <a:bodyPr lIns="0" rIns="0" rtlCol="0" anchor="ctr"/>
-              <a:lstStyle/>
-              <a:p>
-                <a:pPr algn="ctr"/>
-                <a:r>
-                  <a:rPr lang="en-US" dirty="0">
-                    <a:solidFill>
-                      <a:schemeClr val="tx1"/>
-                    </a:solidFill>
-                    <a:latin typeface="Times New Roman" panose="02020603050405020304" pitchFamily="18" charset="0"/>
-                    <a:cs typeface="Times New Roman" panose="02020603050405020304" pitchFamily="18" charset="0"/>
-                  </a:rPr>
-                  <a:t>Success</a:t>
-                </a:r>
-              </a:p>
-            </p:txBody>
-          </p:sp>
-          <p:cxnSp>
-            <p:nvCxnSpPr>
-              <p:cNvPr id="44" name="Straight Arrow Connector 43">
-                <a:extLst>
-                  <a:ext uri="{FF2B5EF4-FFF2-40B4-BE49-F238E27FC236}">
-                    <a16:creationId xmlns:a16="http://schemas.microsoft.com/office/drawing/2014/main" id="{CF022204-AA26-E44B-E9F2-FCAF2D12841D}"/>
-                  </a:ext>
-                </a:extLst>
-              </p:cNvPr>
-              <p:cNvCxnSpPr>
-                <a:cxnSpLocks/>
-                <a:stCxn id="43" idx="4"/>
-                <a:endCxn id="42" idx="0"/>
-              </p:cNvCxnSpPr>
-              <p:nvPr/>
-            </p:nvCxnSpPr>
-            <p:spPr>
-              <a:xfrm flipH="1">
-                <a:off x="7268490" y="3707605"/>
-                <a:ext cx="434116" cy="942389"/>
-              </a:xfrm>
-              <a:prstGeom prst="straightConnector1">
-                <a:avLst/>
-              </a:prstGeom>
-              <a:ln w="19050">
-                <a:solidFill>
-                  <a:schemeClr val="tx1"/>
-                </a:solidFill>
-                <a:tailEnd type="triangle"/>
-              </a:ln>
-            </p:spPr>
-            <p:style>
-              <a:lnRef idx="1">
-                <a:schemeClr val="accent1"/>
-              </a:lnRef>
-              <a:fillRef idx="0">
-                <a:schemeClr val="accent1"/>
-              </a:fillRef>
-              <a:effectRef idx="0">
-                <a:schemeClr val="accent1"/>
-              </a:effectRef>
-              <a:fontRef idx="minor">
-                <a:schemeClr val="tx1"/>
-              </a:fontRef>
-            </p:style>
-          </p:cxnSp>
-          <p:sp>
-            <p:nvSpPr>
-              <p:cNvPr id="45" name="Oval 44">
-                <a:extLst>
-                  <a:ext uri="{FF2B5EF4-FFF2-40B4-BE49-F238E27FC236}">
-                    <a16:creationId xmlns:a16="http://schemas.microsoft.com/office/drawing/2014/main" id="{5FCE2E04-D87E-9E08-ED70-4BA402EE8174}"/>
-                  </a:ext>
-                </a:extLst>
-              </p:cNvPr>
-              <p:cNvSpPr>
-                <a:spLocks noChangeAspect="1"/>
-              </p:cNvSpPr>
-              <p:nvPr/>
-            </p:nvSpPr>
-            <p:spPr>
-              <a:xfrm>
-                <a:off x="6933366" y="5673468"/>
-                <a:ext cx="680891" cy="666648"/>
-              </a:xfrm>
-              <a:prstGeom prst="ellipse">
-                <a:avLst/>
-              </a:prstGeom>
-              <a:solidFill>
-                <a:schemeClr val="bg1"/>
-              </a:solidFill>
-              <a:ln w="19050">
-                <a:solidFill>
-                  <a:schemeClr val="tx1"/>
-                </a:solidFill>
-              </a:ln>
-            </p:spPr>
-            <p:style>
-              <a:lnRef idx="2">
-                <a:schemeClr val="accent1">
-                  <a:shade val="50000"/>
-                </a:schemeClr>
-              </a:lnRef>
-              <a:fillRef idx="1">
-                <a:schemeClr val="accent1"/>
-              </a:fillRef>
-              <a:effectRef idx="0">
-                <a:schemeClr val="accent1"/>
-              </a:effectRef>
-              <a:fontRef idx="minor">
-                <a:schemeClr val="lt1"/>
-              </a:fontRef>
-            </p:style>
-            <p:txBody>
-              <a:bodyPr rtlCol="0" anchor="ctr"/>
-              <a:lstStyle/>
-              <a:p>
-                <a:pPr algn="ctr"/>
-                <a:r>
-                  <a:rPr lang="en-US" sz="1600" dirty="0">
-                    <a:solidFill>
-                      <a:schemeClr val="tx1"/>
-                    </a:solidFill>
-                    <a:latin typeface="Times New Roman" panose="02020603050405020304" pitchFamily="18" charset="0"/>
-                    <a:cs typeface="Times New Roman" panose="02020603050405020304" pitchFamily="18" charset="0"/>
-                  </a:rPr>
-                  <a:t>u</a:t>
-                </a:r>
-                <a:r>
-                  <a:rPr lang="en-US" sz="1600" baseline="-25000" dirty="0">
-                    <a:solidFill>
-                      <a:schemeClr val="tx1"/>
-                    </a:solidFill>
-                    <a:latin typeface="Times New Roman" panose="02020603050405020304" pitchFamily="18" charset="0"/>
-                    <a:cs typeface="Times New Roman" panose="02020603050405020304" pitchFamily="18" charset="0"/>
-                  </a:rPr>
-                  <a:t>S2</a:t>
-                </a:r>
-                <a:endParaRPr lang="en-US" sz="1600" dirty="0">
-                  <a:solidFill>
-                    <a:schemeClr val="tx1"/>
-                  </a:solidFill>
-                  <a:latin typeface="Times New Roman" panose="02020603050405020304" pitchFamily="18" charset="0"/>
-                  <a:cs typeface="Times New Roman" panose="02020603050405020304" pitchFamily="18" charset="0"/>
-                </a:endParaRPr>
-              </a:p>
-            </p:txBody>
-          </p:sp>
-          <p:cxnSp>
-            <p:nvCxnSpPr>
-              <p:cNvPr id="46" name="Straight Arrow Connector 45">
-                <a:extLst>
-                  <a:ext uri="{FF2B5EF4-FFF2-40B4-BE49-F238E27FC236}">
-                    <a16:creationId xmlns:a16="http://schemas.microsoft.com/office/drawing/2014/main" id="{7F359063-3537-3189-6A34-D0AD0F32A672}"/>
-                  </a:ext>
-                </a:extLst>
-              </p:cNvPr>
-              <p:cNvCxnSpPr>
-                <a:cxnSpLocks/>
-                <a:stCxn id="42" idx="2"/>
-                <a:endCxn id="45" idx="0"/>
-              </p:cNvCxnSpPr>
-              <p:nvPr/>
-            </p:nvCxnSpPr>
-            <p:spPr>
-              <a:xfrm>
-                <a:off x="7268490" y="5399879"/>
-                <a:ext cx="5322" cy="273589"/>
-              </a:xfrm>
-              <a:prstGeom prst="straightConnector1">
-                <a:avLst/>
-              </a:prstGeom>
-              <a:ln w="19050">
-                <a:solidFill>
-                  <a:schemeClr val="tx1"/>
-                </a:solidFill>
-                <a:tailEnd type="triangle"/>
-              </a:ln>
-            </p:spPr>
-            <p:style>
-              <a:lnRef idx="1">
-                <a:schemeClr val="accent1"/>
-              </a:lnRef>
-              <a:fillRef idx="0">
-                <a:schemeClr val="accent1"/>
-              </a:fillRef>
-              <a:effectRef idx="0">
-                <a:schemeClr val="accent1"/>
-              </a:effectRef>
-              <a:fontRef idx="minor">
-                <a:schemeClr val="tx1"/>
-              </a:fontRef>
-            </p:style>
-          </p:cxnSp>
-          <p:sp>
-            <p:nvSpPr>
-              <p:cNvPr id="47" name="Rectangle 46">
-                <a:extLst>
-                  <a:ext uri="{FF2B5EF4-FFF2-40B4-BE49-F238E27FC236}">
-                    <a16:creationId xmlns:a16="http://schemas.microsoft.com/office/drawing/2014/main" id="{6217ED45-A65E-284F-4410-7D6F977EC708}"/>
-                  </a:ext>
-                </a:extLst>
-              </p:cNvPr>
-              <p:cNvSpPr/>
-              <p:nvPr/>
-            </p:nvSpPr>
-            <p:spPr>
-              <a:xfrm>
-                <a:off x="7748684" y="4649993"/>
-                <a:ext cx="765907" cy="749885"/>
-              </a:xfrm>
-              <a:prstGeom prst="rect">
-                <a:avLst/>
-              </a:prstGeom>
-              <a:solidFill>
-                <a:schemeClr val="bg1"/>
-              </a:solidFill>
-              <a:ln w="19050">
-                <a:solidFill>
-                  <a:schemeClr val="tx1"/>
-                </a:solidFill>
-              </a:ln>
-            </p:spPr>
-            <p:style>
-              <a:lnRef idx="2">
-                <a:schemeClr val="accent1">
-                  <a:shade val="50000"/>
-                </a:schemeClr>
-              </a:lnRef>
-              <a:fillRef idx="1">
-                <a:schemeClr val="accent1"/>
-              </a:fillRef>
-              <a:effectRef idx="0">
-                <a:schemeClr val="accent1"/>
-              </a:effectRef>
-              <a:fontRef idx="minor">
-                <a:schemeClr val="lt1"/>
-              </a:fontRef>
-            </p:style>
-            <p:txBody>
-              <a:bodyPr rot="0" spcFirstLastPara="0" vertOverflow="overflow" horzOverflow="overflow" vert="horz" wrap="square" lIns="53996" tIns="26998" rIns="53996" bIns="26998" numCol="1" spcCol="0" rtlCol="0" fromWordArt="0" anchor="ctr" anchorCtr="0" forceAA="0" compatLnSpc="1">
-                <a:prstTxWarp prst="textNoShape">
-                  <a:avLst/>
-                </a:prstTxWarp>
-                <a:noAutofit/>
-              </a:bodyPr>
-              <a:lstStyle/>
-              <a:p>
-                <a:pPr algn="ctr"/>
-                <a:r>
-                  <a:rPr lang="en-US" dirty="0">
-                    <a:solidFill>
-                      <a:schemeClr val="tx1"/>
-                    </a:solidFill>
-                    <a:latin typeface="Times New Roman" panose="02020603050405020304" pitchFamily="18" charset="0"/>
-                    <a:cs typeface="Times New Roman" panose="02020603050405020304" pitchFamily="18" charset="0"/>
-                  </a:rPr>
-                  <a:t>S3</a:t>
-                </a:r>
-              </a:p>
-            </p:txBody>
-          </p:sp>
-          <p:sp>
-            <p:nvSpPr>
-              <p:cNvPr id="48" name="Oval 47">
-                <a:extLst>
-                  <a:ext uri="{FF2B5EF4-FFF2-40B4-BE49-F238E27FC236}">
-                    <a16:creationId xmlns:a16="http://schemas.microsoft.com/office/drawing/2014/main" id="{32A2AFA9-367C-B3DD-2131-243E68E34F26}"/>
-                  </a:ext>
-                </a:extLst>
-              </p:cNvPr>
-              <p:cNvSpPr>
-                <a:spLocks noChangeAspect="1"/>
-              </p:cNvSpPr>
-              <p:nvPr/>
-            </p:nvSpPr>
-            <p:spPr>
-              <a:xfrm>
-                <a:off x="7791191" y="5673468"/>
-                <a:ext cx="680891" cy="666648"/>
-              </a:xfrm>
-              <a:prstGeom prst="ellipse">
-                <a:avLst/>
-              </a:prstGeom>
-              <a:solidFill>
-                <a:schemeClr val="bg1"/>
-              </a:solidFill>
-              <a:ln w="19050">
-                <a:solidFill>
-                  <a:schemeClr val="tx1"/>
-                </a:solidFill>
-              </a:ln>
-            </p:spPr>
-            <p:style>
-              <a:lnRef idx="2">
-                <a:schemeClr val="accent1">
-                  <a:shade val="50000"/>
-                </a:schemeClr>
-              </a:lnRef>
-              <a:fillRef idx="1">
-                <a:schemeClr val="accent1"/>
-              </a:fillRef>
-              <a:effectRef idx="0">
-                <a:schemeClr val="accent1"/>
-              </a:effectRef>
-              <a:fontRef idx="minor">
-                <a:schemeClr val="lt1"/>
-              </a:fontRef>
-            </p:style>
-            <p:txBody>
-              <a:bodyPr rtlCol="0" anchor="ctr"/>
-              <a:lstStyle/>
-              <a:p>
-                <a:pPr algn="ctr"/>
-                <a:r>
-                  <a:rPr lang="en-US" sz="1600" dirty="0">
-                    <a:solidFill>
-                      <a:schemeClr val="tx1"/>
-                    </a:solidFill>
-                    <a:latin typeface="Times New Roman" panose="02020603050405020304" pitchFamily="18" charset="0"/>
-                    <a:cs typeface="Times New Roman" panose="02020603050405020304" pitchFamily="18" charset="0"/>
-                  </a:rPr>
-                  <a:t>u</a:t>
-                </a:r>
-                <a:r>
-                  <a:rPr lang="en-US" sz="1600" baseline="-25000" dirty="0">
-                    <a:solidFill>
-                      <a:schemeClr val="tx1"/>
-                    </a:solidFill>
-                    <a:latin typeface="Times New Roman" panose="02020603050405020304" pitchFamily="18" charset="0"/>
-                    <a:cs typeface="Times New Roman" panose="02020603050405020304" pitchFamily="18" charset="0"/>
-                  </a:rPr>
-                  <a:t>S3</a:t>
-                </a:r>
-                <a:endParaRPr lang="en-US" sz="1600" dirty="0">
-                  <a:solidFill>
-                    <a:schemeClr val="tx1"/>
-                  </a:solidFill>
-                  <a:latin typeface="Times New Roman" panose="02020603050405020304" pitchFamily="18" charset="0"/>
-                  <a:cs typeface="Times New Roman" panose="02020603050405020304" pitchFamily="18" charset="0"/>
-                </a:endParaRPr>
-              </a:p>
-            </p:txBody>
-          </p:sp>
-          <p:cxnSp>
-            <p:nvCxnSpPr>
-              <p:cNvPr id="49" name="Straight Arrow Connector 48">
-                <a:extLst>
-                  <a:ext uri="{FF2B5EF4-FFF2-40B4-BE49-F238E27FC236}">
-                    <a16:creationId xmlns:a16="http://schemas.microsoft.com/office/drawing/2014/main" id="{A966A6D2-3460-5482-DC56-91A044E78C2A}"/>
-                  </a:ext>
-                </a:extLst>
-              </p:cNvPr>
-              <p:cNvCxnSpPr>
-                <a:cxnSpLocks/>
-                <a:stCxn id="47" idx="2"/>
-                <a:endCxn id="48" idx="0"/>
-              </p:cNvCxnSpPr>
-              <p:nvPr/>
-            </p:nvCxnSpPr>
-            <p:spPr>
-              <a:xfrm flipH="1">
-                <a:off x="8131637" y="5399878"/>
-                <a:ext cx="1" cy="273590"/>
-              </a:xfrm>
-              <a:prstGeom prst="straightConnector1">
-                <a:avLst/>
-              </a:prstGeom>
-              <a:ln w="19050">
-                <a:solidFill>
-                  <a:schemeClr val="tx1"/>
-                </a:solidFill>
-                <a:tailEnd type="triangle"/>
-              </a:ln>
-            </p:spPr>
-            <p:style>
-              <a:lnRef idx="1">
-                <a:schemeClr val="accent1"/>
-              </a:lnRef>
-              <a:fillRef idx="0">
-                <a:schemeClr val="accent1"/>
-              </a:fillRef>
-              <a:effectRef idx="0">
-                <a:schemeClr val="accent1"/>
-              </a:effectRef>
-              <a:fontRef idx="minor">
-                <a:schemeClr val="tx1"/>
-              </a:fontRef>
-            </p:style>
-          </p:cxnSp>
-          <p:sp>
-            <p:nvSpPr>
-              <p:cNvPr id="50" name="Rectangle 49">
-                <a:extLst>
-                  <a:ext uri="{FF2B5EF4-FFF2-40B4-BE49-F238E27FC236}">
-                    <a16:creationId xmlns:a16="http://schemas.microsoft.com/office/drawing/2014/main" id="{169E86DA-34D0-FB02-E10A-B0C5ED14C263}"/>
-                  </a:ext>
-                </a:extLst>
-              </p:cNvPr>
-              <p:cNvSpPr/>
-              <p:nvPr/>
-            </p:nvSpPr>
-            <p:spPr>
-              <a:xfrm>
-                <a:off x="8611832" y="4649992"/>
-                <a:ext cx="765907" cy="749885"/>
-              </a:xfrm>
-              <a:prstGeom prst="rect">
-                <a:avLst/>
-              </a:prstGeom>
-              <a:solidFill>
-                <a:schemeClr val="bg1"/>
-              </a:solidFill>
-              <a:ln w="19050">
-                <a:solidFill>
-                  <a:schemeClr val="tx1"/>
-                </a:solidFill>
-              </a:ln>
-            </p:spPr>
-            <p:style>
-              <a:lnRef idx="2">
-                <a:schemeClr val="accent1">
-                  <a:shade val="50000"/>
-                </a:schemeClr>
-              </a:lnRef>
-              <a:fillRef idx="1">
-                <a:schemeClr val="accent1"/>
-              </a:fillRef>
-              <a:effectRef idx="0">
-                <a:schemeClr val="accent1"/>
-              </a:effectRef>
-              <a:fontRef idx="minor">
-                <a:schemeClr val="lt1"/>
-              </a:fontRef>
-            </p:style>
-            <p:txBody>
-              <a:bodyPr rot="0" spcFirstLastPara="0" vertOverflow="overflow" horzOverflow="overflow" vert="horz" wrap="square" lIns="53996" tIns="26998" rIns="53996" bIns="26998" numCol="1" spcCol="0" rtlCol="0" fromWordArt="0" anchor="ctr" anchorCtr="0" forceAA="0" compatLnSpc="1">
-                <a:prstTxWarp prst="textNoShape">
-                  <a:avLst/>
-                </a:prstTxWarp>
-                <a:noAutofit/>
-              </a:bodyPr>
-              <a:lstStyle/>
-              <a:p>
-                <a:pPr algn="ctr"/>
-                <a:r>
-                  <a:rPr lang="en-US" dirty="0">
-                    <a:solidFill>
-                      <a:schemeClr val="tx1"/>
-                    </a:solidFill>
-                    <a:latin typeface="Times New Roman" panose="02020603050405020304" pitchFamily="18" charset="0"/>
-                    <a:cs typeface="Times New Roman" panose="02020603050405020304" pitchFamily="18" charset="0"/>
-                  </a:rPr>
-                  <a:t>S4</a:t>
-                </a:r>
-              </a:p>
-            </p:txBody>
-          </p:sp>
-          <p:sp>
-            <p:nvSpPr>
-              <p:cNvPr id="51" name="Oval 50">
-                <a:extLst>
-                  <a:ext uri="{FF2B5EF4-FFF2-40B4-BE49-F238E27FC236}">
-                    <a16:creationId xmlns:a16="http://schemas.microsoft.com/office/drawing/2014/main" id="{5B311324-3031-6A0F-4B1B-CCB085EF4180}"/>
-                  </a:ext>
-                </a:extLst>
-              </p:cNvPr>
-              <p:cNvSpPr>
-                <a:spLocks noChangeAspect="1"/>
-              </p:cNvSpPr>
-              <p:nvPr/>
-            </p:nvSpPr>
-            <p:spPr>
-              <a:xfrm>
-                <a:off x="8649016" y="5673468"/>
-                <a:ext cx="680891" cy="666648"/>
-              </a:xfrm>
-              <a:prstGeom prst="ellipse">
-                <a:avLst/>
-              </a:prstGeom>
-              <a:solidFill>
-                <a:schemeClr val="bg1"/>
-              </a:solidFill>
-              <a:ln w="19050">
-                <a:solidFill>
-                  <a:schemeClr val="tx1"/>
-                </a:solidFill>
-              </a:ln>
-            </p:spPr>
-            <p:style>
-              <a:lnRef idx="2">
-                <a:schemeClr val="accent1">
-                  <a:shade val="50000"/>
-                </a:schemeClr>
-              </a:lnRef>
-              <a:fillRef idx="1">
-                <a:schemeClr val="accent1"/>
-              </a:fillRef>
-              <a:effectRef idx="0">
-                <a:schemeClr val="accent1"/>
-              </a:effectRef>
-              <a:fontRef idx="minor">
-                <a:schemeClr val="lt1"/>
-              </a:fontRef>
-            </p:style>
-            <p:txBody>
-              <a:bodyPr rtlCol="0" anchor="ctr"/>
-              <a:lstStyle/>
-              <a:p>
-                <a:pPr algn="ctr"/>
-                <a:r>
-                  <a:rPr lang="en-US" sz="1600" dirty="0">
-                    <a:solidFill>
-                      <a:schemeClr val="tx1"/>
-                    </a:solidFill>
-                    <a:latin typeface="Times New Roman" panose="02020603050405020304" pitchFamily="18" charset="0"/>
-                    <a:cs typeface="Times New Roman" panose="02020603050405020304" pitchFamily="18" charset="0"/>
-                  </a:rPr>
-                  <a:t>u</a:t>
-                </a:r>
-                <a:r>
-                  <a:rPr lang="en-US" sz="1600" baseline="-25000" dirty="0">
-                    <a:solidFill>
-                      <a:schemeClr val="tx1"/>
-                    </a:solidFill>
-                    <a:latin typeface="Times New Roman" panose="02020603050405020304" pitchFamily="18" charset="0"/>
-                    <a:cs typeface="Times New Roman" panose="02020603050405020304" pitchFamily="18" charset="0"/>
-                  </a:rPr>
-                  <a:t>S4</a:t>
-                </a:r>
-                <a:endParaRPr lang="en-US" sz="1600" dirty="0">
-                  <a:solidFill>
-                    <a:schemeClr val="tx1"/>
-                  </a:solidFill>
-                  <a:latin typeface="Times New Roman" panose="02020603050405020304" pitchFamily="18" charset="0"/>
-                  <a:cs typeface="Times New Roman" panose="02020603050405020304" pitchFamily="18" charset="0"/>
-                </a:endParaRPr>
-              </a:p>
-            </p:txBody>
-          </p:sp>
-          <p:cxnSp>
-            <p:nvCxnSpPr>
-              <p:cNvPr id="52" name="Straight Arrow Connector 51">
-                <a:extLst>
-                  <a:ext uri="{FF2B5EF4-FFF2-40B4-BE49-F238E27FC236}">
-                    <a16:creationId xmlns:a16="http://schemas.microsoft.com/office/drawing/2014/main" id="{7547009C-10B5-983E-11B5-93A2EDC59ED2}"/>
-                  </a:ext>
-                </a:extLst>
-              </p:cNvPr>
-              <p:cNvCxnSpPr>
-                <a:cxnSpLocks/>
-                <a:stCxn id="50" idx="2"/>
-                <a:endCxn id="51" idx="0"/>
-              </p:cNvCxnSpPr>
-              <p:nvPr/>
-            </p:nvCxnSpPr>
-            <p:spPr>
-              <a:xfrm flipH="1">
-                <a:off x="8989462" y="5399877"/>
-                <a:ext cx="5324" cy="273591"/>
-              </a:xfrm>
-              <a:prstGeom prst="straightConnector1">
-                <a:avLst/>
-              </a:prstGeom>
-              <a:ln w="19050">
-                <a:solidFill>
-                  <a:schemeClr val="tx1"/>
-                </a:solidFill>
-                <a:tailEnd type="triangle"/>
-              </a:ln>
-            </p:spPr>
-            <p:style>
-              <a:lnRef idx="1">
-                <a:schemeClr val="accent1"/>
-              </a:lnRef>
-              <a:fillRef idx="0">
-                <a:schemeClr val="accent1"/>
-              </a:fillRef>
-              <a:effectRef idx="0">
-                <a:schemeClr val="accent1"/>
-              </a:effectRef>
-              <a:fontRef idx="minor">
-                <a:schemeClr val="tx1"/>
-              </a:fontRef>
-            </p:style>
-          </p:cxnSp>
-          <p:cxnSp>
-            <p:nvCxnSpPr>
-              <p:cNvPr id="53" name="Straight Arrow Connector 52">
-                <a:extLst>
-                  <a:ext uri="{FF2B5EF4-FFF2-40B4-BE49-F238E27FC236}">
-                    <a16:creationId xmlns:a16="http://schemas.microsoft.com/office/drawing/2014/main" id="{ABFD3772-2217-5AE1-8C24-9485D9032B19}"/>
-                  </a:ext>
-                </a:extLst>
-              </p:cNvPr>
-              <p:cNvCxnSpPr>
-                <a:cxnSpLocks/>
-                <a:stCxn id="43" idx="4"/>
-                <a:endCxn id="47" idx="0"/>
-              </p:cNvCxnSpPr>
-              <p:nvPr/>
-            </p:nvCxnSpPr>
-            <p:spPr>
-              <a:xfrm>
-                <a:off x="7702606" y="3707605"/>
-                <a:ext cx="429032" cy="942388"/>
-              </a:xfrm>
-              <a:prstGeom prst="straightConnector1">
-                <a:avLst/>
-              </a:prstGeom>
-              <a:ln w="19050">
-                <a:solidFill>
-                  <a:schemeClr val="tx1"/>
-                </a:solidFill>
-                <a:tailEnd type="triangle"/>
-              </a:ln>
-            </p:spPr>
-            <p:style>
-              <a:lnRef idx="1">
-                <a:schemeClr val="accent1"/>
-              </a:lnRef>
-              <a:fillRef idx="0">
-                <a:schemeClr val="accent1"/>
-              </a:fillRef>
-              <a:effectRef idx="0">
-                <a:schemeClr val="accent1"/>
-              </a:effectRef>
-              <a:fontRef idx="minor">
-                <a:schemeClr val="tx1"/>
-              </a:fontRef>
-            </p:style>
-          </p:cxnSp>
-          <p:cxnSp>
-            <p:nvCxnSpPr>
-              <p:cNvPr id="54" name="Straight Arrow Connector 53">
-                <a:extLst>
-                  <a:ext uri="{FF2B5EF4-FFF2-40B4-BE49-F238E27FC236}">
-                    <a16:creationId xmlns:a16="http://schemas.microsoft.com/office/drawing/2014/main" id="{4ED98428-4E8D-BA94-F5DC-101C807D3CDE}"/>
-                  </a:ext>
-                </a:extLst>
-              </p:cNvPr>
-              <p:cNvCxnSpPr>
-                <a:cxnSpLocks/>
-                <a:stCxn id="43" idx="4"/>
-                <a:endCxn id="50" idx="0"/>
-              </p:cNvCxnSpPr>
-              <p:nvPr/>
-            </p:nvCxnSpPr>
-            <p:spPr>
-              <a:xfrm>
-                <a:off x="7702606" y="3707605"/>
-                <a:ext cx="1292180" cy="942387"/>
-              </a:xfrm>
-              <a:prstGeom prst="straightConnector1">
-                <a:avLst/>
-              </a:prstGeom>
-              <a:ln w="19050">
-                <a:solidFill>
-                  <a:schemeClr val="tx1"/>
-                </a:solidFill>
-                <a:tailEnd type="triangle"/>
-              </a:ln>
-            </p:spPr>
-            <p:style>
-              <a:lnRef idx="1">
-                <a:schemeClr val="accent1"/>
-              </a:lnRef>
-              <a:fillRef idx="0">
-                <a:schemeClr val="accent1"/>
-              </a:fillRef>
-              <a:effectRef idx="0">
-                <a:schemeClr val="accent1"/>
-              </a:effectRef>
-              <a:fontRef idx="minor">
-                <a:schemeClr val="tx1"/>
-              </a:fontRef>
-            </p:style>
-          </p:cxnSp>
-          <p:sp>
-            <p:nvSpPr>
-              <p:cNvPr id="59" name="Rectangle 58">
-                <a:extLst>
-                  <a:ext uri="{FF2B5EF4-FFF2-40B4-BE49-F238E27FC236}">
-                    <a16:creationId xmlns:a16="http://schemas.microsoft.com/office/drawing/2014/main" id="{8C5D2CE2-94AB-0589-BE3A-881BDEB9383A}"/>
-                  </a:ext>
-                </a:extLst>
-              </p:cNvPr>
-              <p:cNvSpPr/>
-              <p:nvPr/>
-            </p:nvSpPr>
-            <p:spPr>
-              <a:xfrm>
-                <a:off x="6022388" y="4649995"/>
-                <a:ext cx="765907" cy="749885"/>
-              </a:xfrm>
-              <a:prstGeom prst="rect">
-                <a:avLst/>
-              </a:prstGeom>
-              <a:solidFill>
-                <a:schemeClr val="bg1"/>
-              </a:solidFill>
-              <a:ln w="19050">
-                <a:solidFill>
-                  <a:schemeClr val="tx1"/>
-                </a:solidFill>
-              </a:ln>
-            </p:spPr>
-            <p:style>
-              <a:lnRef idx="2">
-                <a:schemeClr val="accent1">
-                  <a:shade val="50000"/>
-                </a:schemeClr>
-              </a:lnRef>
-              <a:fillRef idx="1">
-                <a:schemeClr val="accent1"/>
-              </a:fillRef>
-              <a:effectRef idx="0">
-                <a:schemeClr val="accent1"/>
-              </a:effectRef>
-              <a:fontRef idx="minor">
-                <a:schemeClr val="lt1"/>
-              </a:fontRef>
-            </p:style>
-            <p:txBody>
-              <a:bodyPr rot="0" spcFirstLastPara="0" vertOverflow="overflow" horzOverflow="overflow" vert="horz" wrap="square" lIns="53996" tIns="26998" rIns="53996" bIns="26998" numCol="1" spcCol="0" rtlCol="0" fromWordArt="0" anchor="ctr" anchorCtr="0" forceAA="0" compatLnSpc="1">
-                <a:prstTxWarp prst="textNoShape">
-                  <a:avLst/>
-                </a:prstTxWarp>
-                <a:noAutofit/>
-              </a:bodyPr>
-              <a:lstStyle/>
-              <a:p>
-                <a:pPr algn="ctr"/>
-                <a:r>
-                  <a:rPr lang="en-US" dirty="0">
-                    <a:solidFill>
-                      <a:schemeClr val="tx1"/>
-                    </a:solidFill>
-                    <a:latin typeface="Times New Roman" panose="02020603050405020304" pitchFamily="18" charset="0"/>
-                    <a:cs typeface="Times New Roman" panose="02020603050405020304" pitchFamily="18" charset="0"/>
-                  </a:rPr>
-                  <a:t>S1</a:t>
-                </a:r>
-              </a:p>
-            </p:txBody>
-          </p:sp>
-          <p:sp>
-            <p:nvSpPr>
-              <p:cNvPr id="60" name="Oval 59">
-                <a:extLst>
-                  <a:ext uri="{FF2B5EF4-FFF2-40B4-BE49-F238E27FC236}">
-                    <a16:creationId xmlns:a16="http://schemas.microsoft.com/office/drawing/2014/main" id="{0CE32EEE-BB03-6607-BC61-3DEE8E377BAC}"/>
-                  </a:ext>
-                </a:extLst>
-              </p:cNvPr>
-              <p:cNvSpPr>
-                <a:spLocks noChangeAspect="1"/>
-              </p:cNvSpPr>
-              <p:nvPr/>
-            </p:nvSpPr>
-            <p:spPr>
-              <a:xfrm>
-                <a:off x="6070218" y="5673468"/>
-                <a:ext cx="680891" cy="666648"/>
-              </a:xfrm>
-              <a:prstGeom prst="ellipse">
-                <a:avLst/>
-              </a:prstGeom>
-              <a:solidFill>
-                <a:schemeClr val="bg1"/>
-              </a:solidFill>
-              <a:ln w="19050">
-                <a:solidFill>
-                  <a:schemeClr val="tx1"/>
-                </a:solidFill>
-              </a:ln>
-            </p:spPr>
-            <p:style>
-              <a:lnRef idx="2">
-                <a:schemeClr val="accent1">
-                  <a:shade val="50000"/>
-                </a:schemeClr>
-              </a:lnRef>
-              <a:fillRef idx="1">
-                <a:schemeClr val="accent1"/>
-              </a:fillRef>
-              <a:effectRef idx="0">
-                <a:schemeClr val="accent1"/>
-              </a:effectRef>
-              <a:fontRef idx="minor">
-                <a:schemeClr val="lt1"/>
-              </a:fontRef>
-            </p:style>
-            <p:txBody>
-              <a:bodyPr rtlCol="0" anchor="ctr"/>
-              <a:lstStyle/>
-              <a:p>
-                <a:pPr algn="ctr"/>
-                <a:r>
-                  <a:rPr lang="en-US" sz="1600" dirty="0">
-                    <a:solidFill>
-                      <a:schemeClr val="tx1"/>
-                    </a:solidFill>
-                    <a:latin typeface="Times New Roman" panose="02020603050405020304" pitchFamily="18" charset="0"/>
-                    <a:cs typeface="Times New Roman" panose="02020603050405020304" pitchFamily="18" charset="0"/>
-                  </a:rPr>
-                  <a:t>u</a:t>
-                </a:r>
-                <a:r>
-                  <a:rPr lang="en-US" sz="1600" baseline="-25000" dirty="0">
-                    <a:solidFill>
-                      <a:schemeClr val="tx1"/>
-                    </a:solidFill>
-                    <a:latin typeface="Times New Roman" panose="02020603050405020304" pitchFamily="18" charset="0"/>
-                    <a:cs typeface="Times New Roman" panose="02020603050405020304" pitchFamily="18" charset="0"/>
-                  </a:rPr>
-                  <a:t>S1</a:t>
-                </a:r>
-                <a:endParaRPr lang="en-US" sz="1600" dirty="0">
-                  <a:solidFill>
-                    <a:schemeClr val="tx1"/>
-                  </a:solidFill>
-                  <a:latin typeface="Times New Roman" panose="02020603050405020304" pitchFamily="18" charset="0"/>
-                  <a:cs typeface="Times New Roman" panose="02020603050405020304" pitchFamily="18" charset="0"/>
-                </a:endParaRPr>
-              </a:p>
-            </p:txBody>
-          </p:sp>
-          <p:cxnSp>
-            <p:nvCxnSpPr>
-              <p:cNvPr id="61" name="Straight Arrow Connector 60">
-                <a:extLst>
-                  <a:ext uri="{FF2B5EF4-FFF2-40B4-BE49-F238E27FC236}">
-                    <a16:creationId xmlns:a16="http://schemas.microsoft.com/office/drawing/2014/main" id="{0E481BEE-C6B5-A31F-A5A4-C1D3A86D72C5}"/>
-                  </a:ext>
-                </a:extLst>
-              </p:cNvPr>
-              <p:cNvCxnSpPr>
-                <a:cxnSpLocks/>
-                <a:stCxn id="59" idx="2"/>
-                <a:endCxn id="60" idx="0"/>
-              </p:cNvCxnSpPr>
-              <p:nvPr/>
-            </p:nvCxnSpPr>
-            <p:spPr>
-              <a:xfrm>
-                <a:off x="6405342" y="5399880"/>
-                <a:ext cx="5322" cy="273588"/>
-              </a:xfrm>
-              <a:prstGeom prst="straightConnector1">
-                <a:avLst/>
-              </a:prstGeom>
-              <a:ln w="19050">
-                <a:solidFill>
-                  <a:schemeClr val="tx1"/>
-                </a:solidFill>
-                <a:tailEnd type="triangle"/>
-              </a:ln>
-            </p:spPr>
-            <p:style>
-              <a:lnRef idx="1">
-                <a:schemeClr val="accent1"/>
-              </a:lnRef>
-              <a:fillRef idx="0">
-                <a:schemeClr val="accent1"/>
-              </a:fillRef>
-              <a:effectRef idx="0">
-                <a:schemeClr val="accent1"/>
-              </a:effectRef>
-              <a:fontRef idx="minor">
-                <a:schemeClr val="tx1"/>
-              </a:fontRef>
-            </p:style>
-          </p:cxnSp>
-          <p:cxnSp>
-            <p:nvCxnSpPr>
-              <p:cNvPr id="70" name="Straight Arrow Connector 69">
-                <a:extLst>
-                  <a:ext uri="{FF2B5EF4-FFF2-40B4-BE49-F238E27FC236}">
-                    <a16:creationId xmlns:a16="http://schemas.microsoft.com/office/drawing/2014/main" id="{8561935E-2FE0-388A-F3E1-04B0BE5F333B}"/>
-                  </a:ext>
-                </a:extLst>
-              </p:cNvPr>
-              <p:cNvCxnSpPr>
-                <a:cxnSpLocks/>
-                <a:stCxn id="43" idx="4"/>
-                <a:endCxn id="59" idx="0"/>
-              </p:cNvCxnSpPr>
-              <p:nvPr/>
-            </p:nvCxnSpPr>
-            <p:spPr>
-              <a:xfrm flipH="1">
-                <a:off x="6405342" y="3707605"/>
-                <a:ext cx="1297264" cy="942390"/>
-              </a:xfrm>
-              <a:prstGeom prst="straightConnector1">
-                <a:avLst/>
-              </a:prstGeom>
-              <a:ln w="19050">
-                <a:solidFill>
-                  <a:schemeClr val="tx1"/>
-                </a:solidFill>
-                <a:tailEnd type="triangle"/>
-              </a:ln>
-            </p:spPr>
-            <p:style>
-              <a:lnRef idx="1">
-                <a:schemeClr val="accent1"/>
-              </a:lnRef>
-              <a:fillRef idx="0">
-                <a:schemeClr val="accent1"/>
-              </a:fillRef>
-              <a:effectRef idx="0">
-                <a:schemeClr val="accent1"/>
-              </a:effectRef>
-              <a:fontRef idx="minor">
-                <a:schemeClr val="tx1"/>
-              </a:fontRef>
-            </p:style>
-          </p:cxnSp>
-        </p:grpSp>
-        <p:cxnSp>
-          <p:nvCxnSpPr>
-            <p:cNvPr id="116" name="Connector: Curved 115">
-              <a:extLst>
-                <a:ext uri="{FF2B5EF4-FFF2-40B4-BE49-F238E27FC236}">
-                  <a16:creationId xmlns:a16="http://schemas.microsoft.com/office/drawing/2014/main" id="{ED34FDB0-98C7-ABAF-F350-A58E1143C9AF}"/>
-                </a:ext>
-              </a:extLst>
-            </p:cNvPr>
-            <p:cNvCxnSpPr>
-              <a:cxnSpLocks/>
-              <a:stCxn id="91" idx="0"/>
-              <a:endCxn id="43" idx="0"/>
-            </p:cNvCxnSpPr>
-            <p:nvPr/>
-          </p:nvCxnSpPr>
-          <p:spPr>
-            <a:xfrm rot="5400000" flipH="1" flipV="1">
-              <a:off x="4365206" y="-1337745"/>
-              <a:ext cx="12700" cy="4377155"/>
-            </a:xfrm>
-            <a:prstGeom prst="curvedConnector3">
-              <a:avLst>
-                <a:gd name="adj1" fmla="val 5025000"/>
-              </a:avLst>
-            </a:prstGeom>
-            <a:ln w="19050">
+                <a:latin typeface="Times New Roman" panose="02020603050405020304" pitchFamily="18" charset="0"/>
+                <a:cs typeface="Times New Roman" panose="02020603050405020304" pitchFamily="18" charset="0"/>
+              </a:rPr>
+              <a:t>D1</a:t>
+            </a:r>
+            <a:endParaRPr lang="en-US" sz="1600" dirty="0">
               <a:solidFill>
                 <a:schemeClr val="tx1"/>
               </a:solidFill>
-              <a:headEnd type="triangle"/>
-              <a:tailEnd type="triangle"/>
-            </a:ln>
-          </p:spPr>
-          <p:style>
-            <a:lnRef idx="1">
-              <a:schemeClr val="accent1"/>
-            </a:lnRef>
-            <a:fillRef idx="0">
-              <a:schemeClr val="accent1"/>
-            </a:fillRef>
-            <a:effectRef idx="0">
-              <a:schemeClr val="accent1"/>
-            </a:effectRef>
-            <a:fontRef idx="minor">
+              <a:latin typeface="Times New Roman" panose="02020603050405020304" pitchFamily="18" charset="0"/>
+              <a:cs typeface="Times New Roman" panose="02020603050405020304" pitchFamily="18" charset="0"/>
+            </a:endParaRPr>
+          </a:p>
+        </p:txBody>
+      </p:sp>
+      <p:cxnSp>
+        <p:nvCxnSpPr>
+          <p:cNvPr id="102" name="Straight Arrow Connector 101">
+            <a:extLst>
+              <a:ext uri="{FF2B5EF4-FFF2-40B4-BE49-F238E27FC236}">
+                <a16:creationId xmlns:a16="http://schemas.microsoft.com/office/drawing/2014/main" id="{472D759D-5652-407E-A1EB-EE29B8B90E81}"/>
+              </a:ext>
+            </a:extLst>
+          </p:cNvPr>
+          <p:cNvCxnSpPr>
+            <a:cxnSpLocks/>
+            <a:stCxn id="88" idx="2"/>
+            <a:endCxn id="95" idx="0"/>
+          </p:cNvCxnSpPr>
+          <p:nvPr/>
+        </p:nvCxnSpPr>
+        <p:spPr>
+          <a:xfrm flipH="1">
+            <a:off x="1111069" y="4143060"/>
+            <a:ext cx="1" cy="273587"/>
+          </a:xfrm>
+          <a:prstGeom prst="straightConnector1">
+            <a:avLst/>
+          </a:prstGeom>
+          <a:ln w="19050">
+            <a:solidFill>
               <a:schemeClr val="tx1"/>
-            </a:fontRef>
-          </p:style>
-        </p:cxnSp>
-      </p:grpSp>
+            </a:solidFill>
+            <a:headEnd type="triangle" w="med" len="med"/>
+            <a:tailEnd type="none" w="med" len="med"/>
+          </a:ln>
+        </p:spPr>
+        <p:style>
+          <a:lnRef idx="1">
+            <a:schemeClr val="accent1"/>
+          </a:lnRef>
+          <a:fillRef idx="0">
+            <a:schemeClr val="accent1"/>
+          </a:fillRef>
+          <a:effectRef idx="0">
+            <a:schemeClr val="accent1"/>
+          </a:effectRef>
+          <a:fontRef idx="minor">
+            <a:schemeClr val="tx1"/>
+          </a:fontRef>
+        </p:style>
+      </p:cxnSp>
+      <p:sp>
+        <p:nvSpPr>
+          <p:cNvPr id="16" name="Rectangle 15">
+            <a:extLst>
+              <a:ext uri="{FF2B5EF4-FFF2-40B4-BE49-F238E27FC236}">
+                <a16:creationId xmlns:a16="http://schemas.microsoft.com/office/drawing/2014/main" id="{EDA56541-603C-6B23-A371-DC00A83D968B}"/>
+              </a:ext>
+            </a:extLst>
+          </p:cNvPr>
+          <p:cNvSpPr/>
+          <p:nvPr/>
+        </p:nvSpPr>
+        <p:spPr>
+          <a:xfrm>
+            <a:off x="1793677" y="3393175"/>
+            <a:ext cx="765907" cy="749885"/>
+          </a:xfrm>
+          <a:prstGeom prst="rect">
+            <a:avLst/>
+          </a:prstGeom>
+          <a:solidFill>
+            <a:schemeClr val="bg1"/>
+          </a:solidFill>
+          <a:ln w="19050">
+            <a:solidFill>
+              <a:schemeClr val="tx1"/>
+            </a:solidFill>
+          </a:ln>
+        </p:spPr>
+        <p:style>
+          <a:lnRef idx="2">
+            <a:schemeClr val="accent1">
+              <a:shade val="50000"/>
+            </a:schemeClr>
+          </a:lnRef>
+          <a:fillRef idx="1">
+            <a:schemeClr val="accent1"/>
+          </a:fillRef>
+          <a:effectRef idx="0">
+            <a:schemeClr val="accent1"/>
+          </a:effectRef>
+          <a:fontRef idx="minor">
+            <a:schemeClr val="lt1"/>
+          </a:fontRef>
+        </p:style>
+        <p:txBody>
+          <a:bodyPr rot="0" spcFirstLastPara="0" vertOverflow="overflow" horzOverflow="overflow" vert="horz" wrap="square" lIns="53996" tIns="26998" rIns="53996" bIns="26998" numCol="1" spcCol="0" rtlCol="0" fromWordArt="0" anchor="ctr" anchorCtr="0" forceAA="0" compatLnSpc="1">
+            <a:prstTxWarp prst="textNoShape">
+              <a:avLst/>
+            </a:prstTxWarp>
+            <a:noAutofit/>
+          </a:bodyPr>
+          <a:lstStyle/>
+          <a:p>
+            <a:pPr algn="ctr"/>
+            <a:r>
+              <a:rPr lang="en-US" dirty="0">
+                <a:solidFill>
+                  <a:schemeClr val="tx1"/>
+                </a:solidFill>
+                <a:latin typeface="Times New Roman" panose="02020603050405020304" pitchFamily="18" charset="0"/>
+                <a:cs typeface="Times New Roman" panose="02020603050405020304" pitchFamily="18" charset="0"/>
+              </a:rPr>
+              <a:t>D2</a:t>
+            </a:r>
+          </a:p>
+        </p:txBody>
+      </p:sp>
+      <p:sp>
+        <p:nvSpPr>
+          <p:cNvPr id="17" name="Oval 16">
+            <a:extLst>
+              <a:ext uri="{FF2B5EF4-FFF2-40B4-BE49-F238E27FC236}">
+                <a16:creationId xmlns:a16="http://schemas.microsoft.com/office/drawing/2014/main" id="{837E9B68-BEBC-4E75-B415-B1098982A1E9}"/>
+              </a:ext>
+            </a:extLst>
+          </p:cNvPr>
+          <p:cNvSpPr>
+            <a:spLocks noChangeAspect="1"/>
+          </p:cNvSpPr>
+          <p:nvPr/>
+        </p:nvSpPr>
+        <p:spPr>
+          <a:xfrm>
+            <a:off x="1836184" y="4416647"/>
+            <a:ext cx="680891" cy="666648"/>
+          </a:xfrm>
+          <a:prstGeom prst="ellipse">
+            <a:avLst/>
+          </a:prstGeom>
+          <a:solidFill>
+            <a:schemeClr val="bg1"/>
+          </a:solidFill>
+          <a:ln w="19050">
+            <a:solidFill>
+              <a:schemeClr val="tx1"/>
+            </a:solidFill>
+          </a:ln>
+        </p:spPr>
+        <p:style>
+          <a:lnRef idx="2">
+            <a:schemeClr val="accent1">
+              <a:shade val="50000"/>
+            </a:schemeClr>
+          </a:lnRef>
+          <a:fillRef idx="1">
+            <a:schemeClr val="accent1"/>
+          </a:fillRef>
+          <a:effectRef idx="0">
+            <a:schemeClr val="accent1"/>
+          </a:effectRef>
+          <a:fontRef idx="minor">
+            <a:schemeClr val="lt1"/>
+          </a:fontRef>
+        </p:style>
+        <p:txBody>
+          <a:bodyPr rtlCol="0" anchor="ctr"/>
+          <a:lstStyle/>
+          <a:p>
+            <a:pPr algn="ctr"/>
+            <a:r>
+              <a:rPr lang="en-US" sz="1600" dirty="0">
+                <a:solidFill>
+                  <a:schemeClr val="tx1"/>
+                </a:solidFill>
+                <a:latin typeface="Times New Roman" panose="02020603050405020304" pitchFamily="18" charset="0"/>
+                <a:cs typeface="Times New Roman" panose="02020603050405020304" pitchFamily="18" charset="0"/>
+              </a:rPr>
+              <a:t>u</a:t>
+            </a:r>
+            <a:r>
+              <a:rPr lang="en-US" sz="1600" baseline="-25000" dirty="0">
+                <a:solidFill>
+                  <a:schemeClr val="tx1"/>
+                </a:solidFill>
+                <a:latin typeface="Times New Roman" panose="02020603050405020304" pitchFamily="18" charset="0"/>
+                <a:cs typeface="Times New Roman" panose="02020603050405020304" pitchFamily="18" charset="0"/>
+              </a:rPr>
+              <a:t>D2</a:t>
+            </a:r>
+            <a:endParaRPr lang="en-US" sz="1600" dirty="0">
+              <a:solidFill>
+                <a:schemeClr val="tx1"/>
+              </a:solidFill>
+              <a:latin typeface="Times New Roman" panose="02020603050405020304" pitchFamily="18" charset="0"/>
+              <a:cs typeface="Times New Roman" panose="02020603050405020304" pitchFamily="18" charset="0"/>
+            </a:endParaRPr>
+          </a:p>
+        </p:txBody>
+      </p:sp>
+      <p:cxnSp>
+        <p:nvCxnSpPr>
+          <p:cNvPr id="18" name="Straight Arrow Connector 17">
+            <a:extLst>
+              <a:ext uri="{FF2B5EF4-FFF2-40B4-BE49-F238E27FC236}">
+                <a16:creationId xmlns:a16="http://schemas.microsoft.com/office/drawing/2014/main" id="{105218F0-7F56-F926-5A55-C3AB3D2DD1BD}"/>
+              </a:ext>
+            </a:extLst>
+          </p:cNvPr>
+          <p:cNvCxnSpPr>
+            <a:cxnSpLocks/>
+            <a:stCxn id="16" idx="2"/>
+            <a:endCxn id="17" idx="0"/>
+          </p:cNvCxnSpPr>
+          <p:nvPr/>
+        </p:nvCxnSpPr>
+        <p:spPr>
+          <a:xfrm flipH="1">
+            <a:off x="2176630" y="4143060"/>
+            <a:ext cx="1" cy="273587"/>
+          </a:xfrm>
+          <a:prstGeom prst="straightConnector1">
+            <a:avLst/>
+          </a:prstGeom>
+          <a:ln w="19050">
+            <a:solidFill>
+              <a:schemeClr val="tx1"/>
+            </a:solidFill>
+            <a:headEnd type="triangle" w="med" len="med"/>
+            <a:tailEnd type="none" w="med" len="med"/>
+          </a:ln>
+        </p:spPr>
+        <p:style>
+          <a:lnRef idx="1">
+            <a:schemeClr val="accent1"/>
+          </a:lnRef>
+          <a:fillRef idx="0">
+            <a:schemeClr val="accent1"/>
+          </a:fillRef>
+          <a:effectRef idx="0">
+            <a:schemeClr val="accent1"/>
+          </a:effectRef>
+          <a:fontRef idx="minor">
+            <a:schemeClr val="tx1"/>
+          </a:fontRef>
+        </p:style>
+      </p:cxnSp>
+      <p:sp>
+        <p:nvSpPr>
+          <p:cNvPr id="19" name="Rectangle 18">
+            <a:extLst>
+              <a:ext uri="{FF2B5EF4-FFF2-40B4-BE49-F238E27FC236}">
+                <a16:creationId xmlns:a16="http://schemas.microsoft.com/office/drawing/2014/main" id="{1A48AECE-5FB0-1E8D-749F-F8287A9BB2DA}"/>
+              </a:ext>
+            </a:extLst>
+          </p:cNvPr>
+          <p:cNvSpPr/>
+          <p:nvPr/>
+        </p:nvSpPr>
+        <p:spPr>
+          <a:xfrm>
+            <a:off x="2859236" y="3393174"/>
+            <a:ext cx="765907" cy="749885"/>
+          </a:xfrm>
+          <a:prstGeom prst="rect">
+            <a:avLst/>
+          </a:prstGeom>
+          <a:solidFill>
+            <a:schemeClr val="bg1"/>
+          </a:solidFill>
+          <a:ln w="19050">
+            <a:solidFill>
+              <a:schemeClr val="tx1"/>
+            </a:solidFill>
+          </a:ln>
+        </p:spPr>
+        <p:style>
+          <a:lnRef idx="2">
+            <a:schemeClr val="accent1">
+              <a:shade val="50000"/>
+            </a:schemeClr>
+          </a:lnRef>
+          <a:fillRef idx="1">
+            <a:schemeClr val="accent1"/>
+          </a:fillRef>
+          <a:effectRef idx="0">
+            <a:schemeClr val="accent1"/>
+          </a:effectRef>
+          <a:fontRef idx="minor">
+            <a:schemeClr val="lt1"/>
+          </a:fontRef>
+        </p:style>
+        <p:txBody>
+          <a:bodyPr rot="0" spcFirstLastPara="0" vertOverflow="overflow" horzOverflow="overflow" vert="horz" wrap="square" lIns="53996" tIns="26998" rIns="53996" bIns="26998" numCol="1" spcCol="0" rtlCol="0" fromWordArt="0" anchor="ctr" anchorCtr="0" forceAA="0" compatLnSpc="1">
+            <a:prstTxWarp prst="textNoShape">
+              <a:avLst/>
+            </a:prstTxWarp>
+            <a:noAutofit/>
+          </a:bodyPr>
+          <a:lstStyle/>
+          <a:p>
+            <a:pPr algn="ctr"/>
+            <a:r>
+              <a:rPr lang="en-US" dirty="0">
+                <a:solidFill>
+                  <a:schemeClr val="tx1"/>
+                </a:solidFill>
+                <a:latin typeface="Times New Roman" panose="02020603050405020304" pitchFamily="18" charset="0"/>
+                <a:cs typeface="Times New Roman" panose="02020603050405020304" pitchFamily="18" charset="0"/>
+              </a:rPr>
+              <a:t>D3</a:t>
+            </a:r>
+          </a:p>
+        </p:txBody>
+      </p:sp>
+      <p:sp>
+        <p:nvSpPr>
+          <p:cNvPr id="20" name="Oval 19">
+            <a:extLst>
+              <a:ext uri="{FF2B5EF4-FFF2-40B4-BE49-F238E27FC236}">
+                <a16:creationId xmlns:a16="http://schemas.microsoft.com/office/drawing/2014/main" id="{3BB0E90F-47F7-4BD2-E020-29262840F82A}"/>
+              </a:ext>
+            </a:extLst>
+          </p:cNvPr>
+          <p:cNvSpPr>
+            <a:spLocks noChangeAspect="1"/>
+          </p:cNvSpPr>
+          <p:nvPr/>
+        </p:nvSpPr>
+        <p:spPr>
+          <a:xfrm>
+            <a:off x="2900028" y="4416647"/>
+            <a:ext cx="680891" cy="666648"/>
+          </a:xfrm>
+          <a:prstGeom prst="ellipse">
+            <a:avLst/>
+          </a:prstGeom>
+          <a:solidFill>
+            <a:schemeClr val="bg1"/>
+          </a:solidFill>
+          <a:ln w="19050">
+            <a:solidFill>
+              <a:schemeClr val="tx1"/>
+            </a:solidFill>
+          </a:ln>
+        </p:spPr>
+        <p:style>
+          <a:lnRef idx="2">
+            <a:schemeClr val="accent1">
+              <a:shade val="50000"/>
+            </a:schemeClr>
+          </a:lnRef>
+          <a:fillRef idx="1">
+            <a:schemeClr val="accent1"/>
+          </a:fillRef>
+          <a:effectRef idx="0">
+            <a:schemeClr val="accent1"/>
+          </a:effectRef>
+          <a:fontRef idx="minor">
+            <a:schemeClr val="lt1"/>
+          </a:fontRef>
+        </p:style>
+        <p:txBody>
+          <a:bodyPr rtlCol="0" anchor="ctr"/>
+          <a:lstStyle/>
+          <a:p>
+            <a:pPr algn="ctr"/>
+            <a:r>
+              <a:rPr lang="en-US" sz="1600" dirty="0">
+                <a:solidFill>
+                  <a:schemeClr val="tx1"/>
+                </a:solidFill>
+                <a:latin typeface="Times New Roman" panose="02020603050405020304" pitchFamily="18" charset="0"/>
+                <a:cs typeface="Times New Roman" panose="02020603050405020304" pitchFamily="18" charset="0"/>
+              </a:rPr>
+              <a:t>u</a:t>
+            </a:r>
+            <a:r>
+              <a:rPr lang="en-US" sz="1600" baseline="-25000" dirty="0">
+                <a:solidFill>
+                  <a:schemeClr val="tx1"/>
+                </a:solidFill>
+                <a:latin typeface="Times New Roman" panose="02020603050405020304" pitchFamily="18" charset="0"/>
+                <a:cs typeface="Times New Roman" panose="02020603050405020304" pitchFamily="18" charset="0"/>
+              </a:rPr>
+              <a:t>D3</a:t>
+            </a:r>
+            <a:endParaRPr lang="en-US" sz="1600" dirty="0">
+              <a:solidFill>
+                <a:schemeClr val="tx1"/>
+              </a:solidFill>
+              <a:latin typeface="Times New Roman" panose="02020603050405020304" pitchFamily="18" charset="0"/>
+              <a:cs typeface="Times New Roman" panose="02020603050405020304" pitchFamily="18" charset="0"/>
+            </a:endParaRPr>
+          </a:p>
+        </p:txBody>
+      </p:sp>
+      <p:cxnSp>
+        <p:nvCxnSpPr>
+          <p:cNvPr id="21" name="Straight Arrow Connector 20">
+            <a:extLst>
+              <a:ext uri="{FF2B5EF4-FFF2-40B4-BE49-F238E27FC236}">
+                <a16:creationId xmlns:a16="http://schemas.microsoft.com/office/drawing/2014/main" id="{3FB46C63-8D55-ABC1-3571-4AC1E9E97745}"/>
+              </a:ext>
+            </a:extLst>
+          </p:cNvPr>
+          <p:cNvCxnSpPr>
+            <a:cxnSpLocks/>
+            <a:stCxn id="19" idx="2"/>
+            <a:endCxn id="20" idx="0"/>
+          </p:cNvCxnSpPr>
+          <p:nvPr/>
+        </p:nvCxnSpPr>
+        <p:spPr>
+          <a:xfrm flipH="1">
+            <a:off x="3240474" y="4143059"/>
+            <a:ext cx="1716" cy="273588"/>
+          </a:xfrm>
+          <a:prstGeom prst="straightConnector1">
+            <a:avLst/>
+          </a:prstGeom>
+          <a:ln w="19050">
+            <a:solidFill>
+              <a:schemeClr val="tx1"/>
+            </a:solidFill>
+            <a:headEnd type="triangle" w="med" len="med"/>
+            <a:tailEnd type="none" w="med" len="med"/>
+          </a:ln>
+        </p:spPr>
+        <p:style>
+          <a:lnRef idx="1">
+            <a:schemeClr val="accent1"/>
+          </a:lnRef>
+          <a:fillRef idx="0">
+            <a:schemeClr val="accent1"/>
+          </a:fillRef>
+          <a:effectRef idx="0">
+            <a:schemeClr val="accent1"/>
+          </a:effectRef>
+          <a:fontRef idx="minor">
+            <a:schemeClr val="tx1"/>
+          </a:fontRef>
+        </p:style>
+      </p:cxnSp>
+      <p:cxnSp>
+        <p:nvCxnSpPr>
+          <p:cNvPr id="23" name="Straight Arrow Connector 22">
+            <a:extLst>
+              <a:ext uri="{FF2B5EF4-FFF2-40B4-BE49-F238E27FC236}">
+                <a16:creationId xmlns:a16="http://schemas.microsoft.com/office/drawing/2014/main" id="{A552E9A0-752B-3E8D-11C7-7C26B05B1EDF}"/>
+              </a:ext>
+            </a:extLst>
+          </p:cNvPr>
+          <p:cNvCxnSpPr>
+            <a:cxnSpLocks/>
+            <a:stCxn id="91" idx="4"/>
+            <a:endCxn id="16" idx="0"/>
+          </p:cNvCxnSpPr>
+          <p:nvPr/>
+        </p:nvCxnSpPr>
+        <p:spPr>
+          <a:xfrm>
+            <a:off x="2176630" y="2450784"/>
+            <a:ext cx="1" cy="942391"/>
+          </a:xfrm>
+          <a:prstGeom prst="straightConnector1">
+            <a:avLst/>
+          </a:prstGeom>
+          <a:ln w="19050">
+            <a:solidFill>
+              <a:schemeClr val="tx1"/>
+            </a:solidFill>
+            <a:tailEnd type="triangle"/>
+          </a:ln>
+        </p:spPr>
+        <p:style>
+          <a:lnRef idx="1">
+            <a:schemeClr val="accent1"/>
+          </a:lnRef>
+          <a:fillRef idx="0">
+            <a:schemeClr val="accent1"/>
+          </a:fillRef>
+          <a:effectRef idx="0">
+            <a:schemeClr val="accent1"/>
+          </a:effectRef>
+          <a:fontRef idx="minor">
+            <a:schemeClr val="tx1"/>
+          </a:fontRef>
+        </p:style>
+      </p:cxnSp>
+      <p:cxnSp>
+        <p:nvCxnSpPr>
+          <p:cNvPr id="24" name="Straight Arrow Connector 23">
+            <a:extLst>
+              <a:ext uri="{FF2B5EF4-FFF2-40B4-BE49-F238E27FC236}">
+                <a16:creationId xmlns:a16="http://schemas.microsoft.com/office/drawing/2014/main" id="{616D0402-49C2-8E52-97AB-3F476E2F5DD4}"/>
+              </a:ext>
+            </a:extLst>
+          </p:cNvPr>
+          <p:cNvCxnSpPr>
+            <a:cxnSpLocks/>
+            <a:stCxn id="91" idx="4"/>
+            <a:endCxn id="19" idx="0"/>
+          </p:cNvCxnSpPr>
+          <p:nvPr/>
+        </p:nvCxnSpPr>
+        <p:spPr>
+          <a:xfrm>
+            <a:off x="2176630" y="2450784"/>
+            <a:ext cx="1065560" cy="942390"/>
+          </a:xfrm>
+          <a:prstGeom prst="straightConnector1">
+            <a:avLst/>
+          </a:prstGeom>
+          <a:ln w="19050">
+            <a:solidFill>
+              <a:schemeClr val="tx1"/>
+            </a:solidFill>
+            <a:tailEnd type="triangle"/>
+          </a:ln>
+        </p:spPr>
+        <p:style>
+          <a:lnRef idx="1">
+            <a:schemeClr val="accent1"/>
+          </a:lnRef>
+          <a:fillRef idx="0">
+            <a:schemeClr val="accent1"/>
+          </a:fillRef>
+          <a:effectRef idx="0">
+            <a:schemeClr val="accent1"/>
+          </a:effectRef>
+          <a:fontRef idx="minor">
+            <a:schemeClr val="tx1"/>
+          </a:fontRef>
+        </p:style>
+      </p:cxnSp>
+      <p:sp>
+        <p:nvSpPr>
+          <p:cNvPr id="42" name="Rectangle 41">
+            <a:extLst>
+              <a:ext uri="{FF2B5EF4-FFF2-40B4-BE49-F238E27FC236}">
+                <a16:creationId xmlns:a16="http://schemas.microsoft.com/office/drawing/2014/main" id="{06695606-0BC6-8CFA-F6B2-4C1D8593FA58}"/>
+              </a:ext>
+            </a:extLst>
+          </p:cNvPr>
+          <p:cNvSpPr/>
+          <p:nvPr/>
+        </p:nvSpPr>
+        <p:spPr>
+          <a:xfrm>
+            <a:off x="5736715" y="3393173"/>
+            <a:ext cx="765907" cy="749885"/>
+          </a:xfrm>
+          <a:prstGeom prst="rect">
+            <a:avLst/>
+          </a:prstGeom>
+          <a:solidFill>
+            <a:schemeClr val="bg1"/>
+          </a:solidFill>
+          <a:ln w="19050">
+            <a:solidFill>
+              <a:schemeClr val="tx1"/>
+            </a:solidFill>
+          </a:ln>
+        </p:spPr>
+        <p:style>
+          <a:lnRef idx="2">
+            <a:schemeClr val="accent1">
+              <a:shade val="50000"/>
+            </a:schemeClr>
+          </a:lnRef>
+          <a:fillRef idx="1">
+            <a:schemeClr val="accent1"/>
+          </a:fillRef>
+          <a:effectRef idx="0">
+            <a:schemeClr val="accent1"/>
+          </a:effectRef>
+          <a:fontRef idx="minor">
+            <a:schemeClr val="lt1"/>
+          </a:fontRef>
+        </p:style>
+        <p:txBody>
+          <a:bodyPr rot="0" spcFirstLastPara="0" vertOverflow="overflow" horzOverflow="overflow" vert="horz" wrap="square" lIns="53996" tIns="26998" rIns="53996" bIns="26998" numCol="1" spcCol="0" rtlCol="0" fromWordArt="0" anchor="ctr" anchorCtr="0" forceAA="0" compatLnSpc="1">
+            <a:prstTxWarp prst="textNoShape">
+              <a:avLst/>
+            </a:prstTxWarp>
+            <a:noAutofit/>
+          </a:bodyPr>
+          <a:lstStyle/>
+          <a:p>
+            <a:pPr algn="ctr"/>
+            <a:r>
+              <a:rPr lang="en-US" dirty="0">
+                <a:solidFill>
+                  <a:schemeClr val="tx1"/>
+                </a:solidFill>
+                <a:latin typeface="Times New Roman" panose="02020603050405020304" pitchFamily="18" charset="0"/>
+                <a:cs typeface="Times New Roman" panose="02020603050405020304" pitchFamily="18" charset="0"/>
+              </a:rPr>
+              <a:t>S2</a:t>
+            </a:r>
+          </a:p>
+        </p:txBody>
+      </p:sp>
+      <p:sp>
+        <p:nvSpPr>
+          <p:cNvPr id="43" name="Oval 42">
+            <a:extLst>
+              <a:ext uri="{FF2B5EF4-FFF2-40B4-BE49-F238E27FC236}">
+                <a16:creationId xmlns:a16="http://schemas.microsoft.com/office/drawing/2014/main" id="{380BBA56-8402-9591-70AB-9E4CD467E110}"/>
+              </a:ext>
+            </a:extLst>
+          </p:cNvPr>
+          <p:cNvSpPr/>
+          <p:nvPr/>
+        </p:nvSpPr>
+        <p:spPr>
+          <a:xfrm>
+            <a:off x="5736715" y="850832"/>
+            <a:ext cx="1634140" cy="1599952"/>
+          </a:xfrm>
+          <a:prstGeom prst="ellipse">
+            <a:avLst/>
+          </a:prstGeom>
+          <a:solidFill>
+            <a:schemeClr val="bg1"/>
+          </a:solidFill>
+          <a:ln w="19050">
+            <a:solidFill>
+              <a:schemeClr val="tx1"/>
+            </a:solidFill>
+          </a:ln>
+        </p:spPr>
+        <p:style>
+          <a:lnRef idx="2">
+            <a:schemeClr val="accent1">
+              <a:shade val="50000"/>
+            </a:schemeClr>
+          </a:lnRef>
+          <a:fillRef idx="1">
+            <a:schemeClr val="accent1"/>
+          </a:fillRef>
+          <a:effectRef idx="0">
+            <a:schemeClr val="accent1"/>
+          </a:effectRef>
+          <a:fontRef idx="minor">
+            <a:schemeClr val="lt1"/>
+          </a:fontRef>
+        </p:style>
+        <p:txBody>
+          <a:bodyPr lIns="0" rIns="0" rtlCol="0" anchor="ctr"/>
+          <a:lstStyle/>
+          <a:p>
+            <a:pPr algn="ctr"/>
+            <a:r>
+              <a:rPr lang="en-US" dirty="0">
+                <a:solidFill>
+                  <a:schemeClr val="tx1"/>
+                </a:solidFill>
+                <a:latin typeface="Times New Roman" panose="02020603050405020304" pitchFamily="18" charset="0"/>
+                <a:cs typeface="Times New Roman" panose="02020603050405020304" pitchFamily="18" charset="0"/>
+              </a:rPr>
+              <a:t>Success</a:t>
+            </a:r>
+          </a:p>
+        </p:txBody>
+      </p:sp>
+      <p:cxnSp>
+        <p:nvCxnSpPr>
+          <p:cNvPr id="44" name="Straight Arrow Connector 43">
+            <a:extLst>
+              <a:ext uri="{FF2B5EF4-FFF2-40B4-BE49-F238E27FC236}">
+                <a16:creationId xmlns:a16="http://schemas.microsoft.com/office/drawing/2014/main" id="{CF022204-AA26-E44B-E9F2-FCAF2D12841D}"/>
+              </a:ext>
+            </a:extLst>
+          </p:cNvPr>
+          <p:cNvCxnSpPr>
+            <a:cxnSpLocks/>
+            <a:stCxn id="43" idx="4"/>
+            <a:endCxn id="42" idx="0"/>
+          </p:cNvCxnSpPr>
+          <p:nvPr/>
+        </p:nvCxnSpPr>
+        <p:spPr>
+          <a:xfrm flipH="1">
+            <a:off x="6119669" y="2450784"/>
+            <a:ext cx="434116" cy="942389"/>
+          </a:xfrm>
+          <a:prstGeom prst="straightConnector1">
+            <a:avLst/>
+          </a:prstGeom>
+          <a:ln w="19050">
+            <a:solidFill>
+              <a:schemeClr val="tx1"/>
+            </a:solidFill>
+            <a:tailEnd type="triangle"/>
+          </a:ln>
+        </p:spPr>
+        <p:style>
+          <a:lnRef idx="1">
+            <a:schemeClr val="accent1"/>
+          </a:lnRef>
+          <a:fillRef idx="0">
+            <a:schemeClr val="accent1"/>
+          </a:fillRef>
+          <a:effectRef idx="0">
+            <a:schemeClr val="accent1"/>
+          </a:effectRef>
+          <a:fontRef idx="minor">
+            <a:schemeClr val="tx1"/>
+          </a:fontRef>
+        </p:style>
+      </p:cxnSp>
+      <p:sp>
+        <p:nvSpPr>
+          <p:cNvPr id="45" name="Oval 44">
+            <a:extLst>
+              <a:ext uri="{FF2B5EF4-FFF2-40B4-BE49-F238E27FC236}">
+                <a16:creationId xmlns:a16="http://schemas.microsoft.com/office/drawing/2014/main" id="{5FCE2E04-D87E-9E08-ED70-4BA402EE8174}"/>
+              </a:ext>
+            </a:extLst>
+          </p:cNvPr>
+          <p:cNvSpPr>
+            <a:spLocks noChangeAspect="1"/>
+          </p:cNvSpPr>
+          <p:nvPr/>
+        </p:nvSpPr>
+        <p:spPr>
+          <a:xfrm>
+            <a:off x="5784545" y="4416647"/>
+            <a:ext cx="680891" cy="666648"/>
+          </a:xfrm>
+          <a:prstGeom prst="ellipse">
+            <a:avLst/>
+          </a:prstGeom>
+          <a:solidFill>
+            <a:schemeClr val="bg1"/>
+          </a:solidFill>
+          <a:ln w="19050">
+            <a:solidFill>
+              <a:schemeClr val="tx1"/>
+            </a:solidFill>
+          </a:ln>
+        </p:spPr>
+        <p:style>
+          <a:lnRef idx="2">
+            <a:schemeClr val="accent1">
+              <a:shade val="50000"/>
+            </a:schemeClr>
+          </a:lnRef>
+          <a:fillRef idx="1">
+            <a:schemeClr val="accent1"/>
+          </a:fillRef>
+          <a:effectRef idx="0">
+            <a:schemeClr val="accent1"/>
+          </a:effectRef>
+          <a:fontRef idx="minor">
+            <a:schemeClr val="lt1"/>
+          </a:fontRef>
+        </p:style>
+        <p:txBody>
+          <a:bodyPr rtlCol="0" anchor="ctr"/>
+          <a:lstStyle/>
+          <a:p>
+            <a:pPr algn="ctr"/>
+            <a:r>
+              <a:rPr lang="en-US" sz="1600" dirty="0">
+                <a:solidFill>
+                  <a:schemeClr val="tx1"/>
+                </a:solidFill>
+                <a:latin typeface="Times New Roman" panose="02020603050405020304" pitchFamily="18" charset="0"/>
+                <a:cs typeface="Times New Roman" panose="02020603050405020304" pitchFamily="18" charset="0"/>
+              </a:rPr>
+              <a:t>u</a:t>
+            </a:r>
+            <a:r>
+              <a:rPr lang="en-US" sz="1600" baseline="-25000" dirty="0">
+                <a:solidFill>
+                  <a:schemeClr val="tx1"/>
+                </a:solidFill>
+                <a:latin typeface="Times New Roman" panose="02020603050405020304" pitchFamily="18" charset="0"/>
+                <a:cs typeface="Times New Roman" panose="02020603050405020304" pitchFamily="18" charset="0"/>
+              </a:rPr>
+              <a:t>S2</a:t>
+            </a:r>
+            <a:endParaRPr lang="en-US" sz="1600" dirty="0">
+              <a:solidFill>
+                <a:schemeClr val="tx1"/>
+              </a:solidFill>
+              <a:latin typeface="Times New Roman" panose="02020603050405020304" pitchFamily="18" charset="0"/>
+              <a:cs typeface="Times New Roman" panose="02020603050405020304" pitchFamily="18" charset="0"/>
+            </a:endParaRPr>
+          </a:p>
+        </p:txBody>
+      </p:sp>
+      <p:cxnSp>
+        <p:nvCxnSpPr>
+          <p:cNvPr id="46" name="Straight Arrow Connector 45">
+            <a:extLst>
+              <a:ext uri="{FF2B5EF4-FFF2-40B4-BE49-F238E27FC236}">
+                <a16:creationId xmlns:a16="http://schemas.microsoft.com/office/drawing/2014/main" id="{7F359063-3537-3189-6A34-D0AD0F32A672}"/>
+              </a:ext>
+            </a:extLst>
+          </p:cNvPr>
+          <p:cNvCxnSpPr>
+            <a:cxnSpLocks/>
+            <a:stCxn id="42" idx="2"/>
+            <a:endCxn id="45" idx="0"/>
+          </p:cNvCxnSpPr>
+          <p:nvPr/>
+        </p:nvCxnSpPr>
+        <p:spPr>
+          <a:xfrm>
+            <a:off x="6119669" y="4143058"/>
+            <a:ext cx="5322" cy="273589"/>
+          </a:xfrm>
+          <a:prstGeom prst="straightConnector1">
+            <a:avLst/>
+          </a:prstGeom>
+          <a:ln w="19050">
+            <a:solidFill>
+              <a:schemeClr val="tx1"/>
+            </a:solidFill>
+            <a:headEnd type="triangle" w="med" len="med"/>
+            <a:tailEnd type="none" w="med" len="med"/>
+          </a:ln>
+        </p:spPr>
+        <p:style>
+          <a:lnRef idx="1">
+            <a:schemeClr val="accent1"/>
+          </a:lnRef>
+          <a:fillRef idx="0">
+            <a:schemeClr val="accent1"/>
+          </a:fillRef>
+          <a:effectRef idx="0">
+            <a:schemeClr val="accent1"/>
+          </a:effectRef>
+          <a:fontRef idx="minor">
+            <a:schemeClr val="tx1"/>
+          </a:fontRef>
+        </p:style>
+      </p:cxnSp>
+      <p:sp>
+        <p:nvSpPr>
+          <p:cNvPr id="47" name="Rectangle 46">
+            <a:extLst>
+              <a:ext uri="{FF2B5EF4-FFF2-40B4-BE49-F238E27FC236}">
+                <a16:creationId xmlns:a16="http://schemas.microsoft.com/office/drawing/2014/main" id="{6217ED45-A65E-284F-4410-7D6F977EC708}"/>
+              </a:ext>
+            </a:extLst>
+          </p:cNvPr>
+          <p:cNvSpPr/>
+          <p:nvPr/>
+        </p:nvSpPr>
+        <p:spPr>
+          <a:xfrm>
+            <a:off x="6599863" y="3393172"/>
+            <a:ext cx="765907" cy="749885"/>
+          </a:xfrm>
+          <a:prstGeom prst="rect">
+            <a:avLst/>
+          </a:prstGeom>
+          <a:solidFill>
+            <a:schemeClr val="bg1"/>
+          </a:solidFill>
+          <a:ln w="19050">
+            <a:solidFill>
+              <a:schemeClr val="tx1"/>
+            </a:solidFill>
+          </a:ln>
+        </p:spPr>
+        <p:style>
+          <a:lnRef idx="2">
+            <a:schemeClr val="accent1">
+              <a:shade val="50000"/>
+            </a:schemeClr>
+          </a:lnRef>
+          <a:fillRef idx="1">
+            <a:schemeClr val="accent1"/>
+          </a:fillRef>
+          <a:effectRef idx="0">
+            <a:schemeClr val="accent1"/>
+          </a:effectRef>
+          <a:fontRef idx="minor">
+            <a:schemeClr val="lt1"/>
+          </a:fontRef>
+        </p:style>
+        <p:txBody>
+          <a:bodyPr rot="0" spcFirstLastPara="0" vertOverflow="overflow" horzOverflow="overflow" vert="horz" wrap="square" lIns="53996" tIns="26998" rIns="53996" bIns="26998" numCol="1" spcCol="0" rtlCol="0" fromWordArt="0" anchor="ctr" anchorCtr="0" forceAA="0" compatLnSpc="1">
+            <a:prstTxWarp prst="textNoShape">
+              <a:avLst/>
+            </a:prstTxWarp>
+            <a:noAutofit/>
+          </a:bodyPr>
+          <a:lstStyle/>
+          <a:p>
+            <a:pPr algn="ctr"/>
+            <a:r>
+              <a:rPr lang="en-US" dirty="0">
+                <a:solidFill>
+                  <a:schemeClr val="tx1"/>
+                </a:solidFill>
+                <a:latin typeface="Times New Roman" panose="02020603050405020304" pitchFamily="18" charset="0"/>
+                <a:cs typeface="Times New Roman" panose="02020603050405020304" pitchFamily="18" charset="0"/>
+              </a:rPr>
+              <a:t>S3</a:t>
+            </a:r>
+          </a:p>
+        </p:txBody>
+      </p:sp>
+      <p:sp>
+        <p:nvSpPr>
+          <p:cNvPr id="48" name="Oval 47">
+            <a:extLst>
+              <a:ext uri="{FF2B5EF4-FFF2-40B4-BE49-F238E27FC236}">
+                <a16:creationId xmlns:a16="http://schemas.microsoft.com/office/drawing/2014/main" id="{32A2AFA9-367C-B3DD-2131-243E68E34F26}"/>
+              </a:ext>
+            </a:extLst>
+          </p:cNvPr>
+          <p:cNvSpPr>
+            <a:spLocks noChangeAspect="1"/>
+          </p:cNvSpPr>
+          <p:nvPr/>
+        </p:nvSpPr>
+        <p:spPr>
+          <a:xfrm>
+            <a:off x="6642370" y="4416647"/>
+            <a:ext cx="680891" cy="666648"/>
+          </a:xfrm>
+          <a:prstGeom prst="ellipse">
+            <a:avLst/>
+          </a:prstGeom>
+          <a:solidFill>
+            <a:schemeClr val="bg1"/>
+          </a:solidFill>
+          <a:ln w="19050">
+            <a:solidFill>
+              <a:schemeClr val="tx1"/>
+            </a:solidFill>
+          </a:ln>
+        </p:spPr>
+        <p:style>
+          <a:lnRef idx="2">
+            <a:schemeClr val="accent1">
+              <a:shade val="50000"/>
+            </a:schemeClr>
+          </a:lnRef>
+          <a:fillRef idx="1">
+            <a:schemeClr val="accent1"/>
+          </a:fillRef>
+          <a:effectRef idx="0">
+            <a:schemeClr val="accent1"/>
+          </a:effectRef>
+          <a:fontRef idx="minor">
+            <a:schemeClr val="lt1"/>
+          </a:fontRef>
+        </p:style>
+        <p:txBody>
+          <a:bodyPr rtlCol="0" anchor="ctr"/>
+          <a:lstStyle/>
+          <a:p>
+            <a:pPr algn="ctr"/>
+            <a:r>
+              <a:rPr lang="en-US" sz="1600" dirty="0">
+                <a:solidFill>
+                  <a:schemeClr val="tx1"/>
+                </a:solidFill>
+                <a:latin typeface="Times New Roman" panose="02020603050405020304" pitchFamily="18" charset="0"/>
+                <a:cs typeface="Times New Roman" panose="02020603050405020304" pitchFamily="18" charset="0"/>
+              </a:rPr>
+              <a:t>u</a:t>
+            </a:r>
+            <a:r>
+              <a:rPr lang="en-US" sz="1600" baseline="-25000" dirty="0">
+                <a:solidFill>
+                  <a:schemeClr val="tx1"/>
+                </a:solidFill>
+                <a:latin typeface="Times New Roman" panose="02020603050405020304" pitchFamily="18" charset="0"/>
+                <a:cs typeface="Times New Roman" panose="02020603050405020304" pitchFamily="18" charset="0"/>
+              </a:rPr>
+              <a:t>S3</a:t>
+            </a:r>
+            <a:endParaRPr lang="en-US" sz="1600" dirty="0">
+              <a:solidFill>
+                <a:schemeClr val="tx1"/>
+              </a:solidFill>
+              <a:latin typeface="Times New Roman" panose="02020603050405020304" pitchFamily="18" charset="0"/>
+              <a:cs typeface="Times New Roman" panose="02020603050405020304" pitchFamily="18" charset="0"/>
+            </a:endParaRPr>
+          </a:p>
+        </p:txBody>
+      </p:sp>
+      <p:cxnSp>
+        <p:nvCxnSpPr>
+          <p:cNvPr id="49" name="Straight Arrow Connector 48">
+            <a:extLst>
+              <a:ext uri="{FF2B5EF4-FFF2-40B4-BE49-F238E27FC236}">
+                <a16:creationId xmlns:a16="http://schemas.microsoft.com/office/drawing/2014/main" id="{A966A6D2-3460-5482-DC56-91A044E78C2A}"/>
+              </a:ext>
+            </a:extLst>
+          </p:cNvPr>
+          <p:cNvCxnSpPr>
+            <a:cxnSpLocks/>
+            <a:stCxn id="47" idx="2"/>
+            <a:endCxn id="48" idx="0"/>
+          </p:cNvCxnSpPr>
+          <p:nvPr/>
+        </p:nvCxnSpPr>
+        <p:spPr>
+          <a:xfrm flipH="1">
+            <a:off x="6982816" y="4143057"/>
+            <a:ext cx="1" cy="273590"/>
+          </a:xfrm>
+          <a:prstGeom prst="straightConnector1">
+            <a:avLst/>
+          </a:prstGeom>
+          <a:ln w="19050">
+            <a:solidFill>
+              <a:schemeClr val="tx1"/>
+            </a:solidFill>
+            <a:headEnd type="triangle" w="med" len="med"/>
+            <a:tailEnd type="none" w="med" len="med"/>
+          </a:ln>
+        </p:spPr>
+        <p:style>
+          <a:lnRef idx="1">
+            <a:schemeClr val="accent1"/>
+          </a:lnRef>
+          <a:fillRef idx="0">
+            <a:schemeClr val="accent1"/>
+          </a:fillRef>
+          <a:effectRef idx="0">
+            <a:schemeClr val="accent1"/>
+          </a:effectRef>
+          <a:fontRef idx="minor">
+            <a:schemeClr val="tx1"/>
+          </a:fontRef>
+        </p:style>
+      </p:cxnSp>
+      <p:sp>
+        <p:nvSpPr>
+          <p:cNvPr id="50" name="Rectangle 49">
+            <a:extLst>
+              <a:ext uri="{FF2B5EF4-FFF2-40B4-BE49-F238E27FC236}">
+                <a16:creationId xmlns:a16="http://schemas.microsoft.com/office/drawing/2014/main" id="{169E86DA-34D0-FB02-E10A-B0C5ED14C263}"/>
+              </a:ext>
+            </a:extLst>
+          </p:cNvPr>
+          <p:cNvSpPr/>
+          <p:nvPr/>
+        </p:nvSpPr>
+        <p:spPr>
+          <a:xfrm>
+            <a:off x="7463011" y="3393171"/>
+            <a:ext cx="765907" cy="749885"/>
+          </a:xfrm>
+          <a:prstGeom prst="rect">
+            <a:avLst/>
+          </a:prstGeom>
+          <a:solidFill>
+            <a:schemeClr val="bg1"/>
+          </a:solidFill>
+          <a:ln w="19050">
+            <a:solidFill>
+              <a:schemeClr val="tx1"/>
+            </a:solidFill>
+          </a:ln>
+        </p:spPr>
+        <p:style>
+          <a:lnRef idx="2">
+            <a:schemeClr val="accent1">
+              <a:shade val="50000"/>
+            </a:schemeClr>
+          </a:lnRef>
+          <a:fillRef idx="1">
+            <a:schemeClr val="accent1"/>
+          </a:fillRef>
+          <a:effectRef idx="0">
+            <a:schemeClr val="accent1"/>
+          </a:effectRef>
+          <a:fontRef idx="minor">
+            <a:schemeClr val="lt1"/>
+          </a:fontRef>
+        </p:style>
+        <p:txBody>
+          <a:bodyPr rot="0" spcFirstLastPara="0" vertOverflow="overflow" horzOverflow="overflow" vert="horz" wrap="square" lIns="53996" tIns="26998" rIns="53996" bIns="26998" numCol="1" spcCol="0" rtlCol="0" fromWordArt="0" anchor="ctr" anchorCtr="0" forceAA="0" compatLnSpc="1">
+            <a:prstTxWarp prst="textNoShape">
+              <a:avLst/>
+            </a:prstTxWarp>
+            <a:noAutofit/>
+          </a:bodyPr>
+          <a:lstStyle/>
+          <a:p>
+            <a:pPr algn="ctr"/>
+            <a:r>
+              <a:rPr lang="en-US" dirty="0">
+                <a:solidFill>
+                  <a:schemeClr val="tx1"/>
+                </a:solidFill>
+                <a:latin typeface="Times New Roman" panose="02020603050405020304" pitchFamily="18" charset="0"/>
+                <a:cs typeface="Times New Roman" panose="02020603050405020304" pitchFamily="18" charset="0"/>
+              </a:rPr>
+              <a:t>S4</a:t>
+            </a:r>
+          </a:p>
+        </p:txBody>
+      </p:sp>
+      <p:sp>
+        <p:nvSpPr>
+          <p:cNvPr id="51" name="Oval 50">
+            <a:extLst>
+              <a:ext uri="{FF2B5EF4-FFF2-40B4-BE49-F238E27FC236}">
+                <a16:creationId xmlns:a16="http://schemas.microsoft.com/office/drawing/2014/main" id="{5B311324-3031-6A0F-4B1B-CCB085EF4180}"/>
+              </a:ext>
+            </a:extLst>
+          </p:cNvPr>
+          <p:cNvSpPr>
+            <a:spLocks noChangeAspect="1"/>
+          </p:cNvSpPr>
+          <p:nvPr/>
+        </p:nvSpPr>
+        <p:spPr>
+          <a:xfrm>
+            <a:off x="7500195" y="4416647"/>
+            <a:ext cx="680891" cy="666648"/>
+          </a:xfrm>
+          <a:prstGeom prst="ellipse">
+            <a:avLst/>
+          </a:prstGeom>
+          <a:solidFill>
+            <a:schemeClr val="bg1"/>
+          </a:solidFill>
+          <a:ln w="19050">
+            <a:solidFill>
+              <a:schemeClr val="tx1"/>
+            </a:solidFill>
+          </a:ln>
+        </p:spPr>
+        <p:style>
+          <a:lnRef idx="2">
+            <a:schemeClr val="accent1">
+              <a:shade val="50000"/>
+            </a:schemeClr>
+          </a:lnRef>
+          <a:fillRef idx="1">
+            <a:schemeClr val="accent1"/>
+          </a:fillRef>
+          <a:effectRef idx="0">
+            <a:schemeClr val="accent1"/>
+          </a:effectRef>
+          <a:fontRef idx="minor">
+            <a:schemeClr val="lt1"/>
+          </a:fontRef>
+        </p:style>
+        <p:txBody>
+          <a:bodyPr rtlCol="0" anchor="ctr"/>
+          <a:lstStyle/>
+          <a:p>
+            <a:pPr algn="ctr"/>
+            <a:r>
+              <a:rPr lang="en-US" sz="1600" dirty="0">
+                <a:solidFill>
+                  <a:schemeClr val="tx1"/>
+                </a:solidFill>
+                <a:latin typeface="Times New Roman" panose="02020603050405020304" pitchFamily="18" charset="0"/>
+                <a:cs typeface="Times New Roman" panose="02020603050405020304" pitchFamily="18" charset="0"/>
+              </a:rPr>
+              <a:t>u</a:t>
+            </a:r>
+            <a:r>
+              <a:rPr lang="en-US" sz="1600" baseline="-25000" dirty="0">
+                <a:solidFill>
+                  <a:schemeClr val="tx1"/>
+                </a:solidFill>
+                <a:latin typeface="Times New Roman" panose="02020603050405020304" pitchFamily="18" charset="0"/>
+                <a:cs typeface="Times New Roman" panose="02020603050405020304" pitchFamily="18" charset="0"/>
+              </a:rPr>
+              <a:t>S4</a:t>
+            </a:r>
+            <a:endParaRPr lang="en-US" sz="1600" dirty="0">
+              <a:solidFill>
+                <a:schemeClr val="tx1"/>
+              </a:solidFill>
+              <a:latin typeface="Times New Roman" panose="02020603050405020304" pitchFamily="18" charset="0"/>
+              <a:cs typeface="Times New Roman" panose="02020603050405020304" pitchFamily="18" charset="0"/>
+            </a:endParaRPr>
+          </a:p>
+        </p:txBody>
+      </p:sp>
+      <p:cxnSp>
+        <p:nvCxnSpPr>
+          <p:cNvPr id="52" name="Straight Arrow Connector 51">
+            <a:extLst>
+              <a:ext uri="{FF2B5EF4-FFF2-40B4-BE49-F238E27FC236}">
+                <a16:creationId xmlns:a16="http://schemas.microsoft.com/office/drawing/2014/main" id="{7547009C-10B5-983E-11B5-93A2EDC59ED2}"/>
+              </a:ext>
+            </a:extLst>
+          </p:cNvPr>
+          <p:cNvCxnSpPr>
+            <a:cxnSpLocks/>
+            <a:stCxn id="50" idx="2"/>
+            <a:endCxn id="51" idx="0"/>
+          </p:cNvCxnSpPr>
+          <p:nvPr/>
+        </p:nvCxnSpPr>
+        <p:spPr>
+          <a:xfrm flipH="1">
+            <a:off x="7840641" y="4143056"/>
+            <a:ext cx="5324" cy="273591"/>
+          </a:xfrm>
+          <a:prstGeom prst="straightConnector1">
+            <a:avLst/>
+          </a:prstGeom>
+          <a:ln w="19050">
+            <a:solidFill>
+              <a:schemeClr val="tx1"/>
+            </a:solidFill>
+            <a:headEnd type="triangle" w="med" len="med"/>
+            <a:tailEnd type="none" w="med" len="med"/>
+          </a:ln>
+        </p:spPr>
+        <p:style>
+          <a:lnRef idx="1">
+            <a:schemeClr val="accent1"/>
+          </a:lnRef>
+          <a:fillRef idx="0">
+            <a:schemeClr val="accent1"/>
+          </a:fillRef>
+          <a:effectRef idx="0">
+            <a:schemeClr val="accent1"/>
+          </a:effectRef>
+          <a:fontRef idx="minor">
+            <a:schemeClr val="tx1"/>
+          </a:fontRef>
+        </p:style>
+      </p:cxnSp>
+      <p:cxnSp>
+        <p:nvCxnSpPr>
+          <p:cNvPr id="53" name="Straight Arrow Connector 52">
+            <a:extLst>
+              <a:ext uri="{FF2B5EF4-FFF2-40B4-BE49-F238E27FC236}">
+                <a16:creationId xmlns:a16="http://schemas.microsoft.com/office/drawing/2014/main" id="{ABFD3772-2217-5AE1-8C24-9485D9032B19}"/>
+              </a:ext>
+            </a:extLst>
+          </p:cNvPr>
+          <p:cNvCxnSpPr>
+            <a:cxnSpLocks/>
+            <a:stCxn id="43" idx="4"/>
+            <a:endCxn id="47" idx="0"/>
+          </p:cNvCxnSpPr>
+          <p:nvPr/>
+        </p:nvCxnSpPr>
+        <p:spPr>
+          <a:xfrm>
+            <a:off x="6553785" y="2450784"/>
+            <a:ext cx="429032" cy="942388"/>
+          </a:xfrm>
+          <a:prstGeom prst="straightConnector1">
+            <a:avLst/>
+          </a:prstGeom>
+          <a:ln w="19050">
+            <a:solidFill>
+              <a:schemeClr val="tx1"/>
+            </a:solidFill>
+            <a:tailEnd type="triangle"/>
+          </a:ln>
+        </p:spPr>
+        <p:style>
+          <a:lnRef idx="1">
+            <a:schemeClr val="accent1"/>
+          </a:lnRef>
+          <a:fillRef idx="0">
+            <a:schemeClr val="accent1"/>
+          </a:fillRef>
+          <a:effectRef idx="0">
+            <a:schemeClr val="accent1"/>
+          </a:effectRef>
+          <a:fontRef idx="minor">
+            <a:schemeClr val="tx1"/>
+          </a:fontRef>
+        </p:style>
+      </p:cxnSp>
+      <p:cxnSp>
+        <p:nvCxnSpPr>
+          <p:cNvPr id="54" name="Straight Arrow Connector 53">
+            <a:extLst>
+              <a:ext uri="{FF2B5EF4-FFF2-40B4-BE49-F238E27FC236}">
+                <a16:creationId xmlns:a16="http://schemas.microsoft.com/office/drawing/2014/main" id="{4ED98428-4E8D-BA94-F5DC-101C807D3CDE}"/>
+              </a:ext>
+            </a:extLst>
+          </p:cNvPr>
+          <p:cNvCxnSpPr>
+            <a:cxnSpLocks/>
+            <a:stCxn id="43" idx="4"/>
+            <a:endCxn id="50" idx="0"/>
+          </p:cNvCxnSpPr>
+          <p:nvPr/>
+        </p:nvCxnSpPr>
+        <p:spPr>
+          <a:xfrm>
+            <a:off x="6553785" y="2450784"/>
+            <a:ext cx="1292180" cy="942387"/>
+          </a:xfrm>
+          <a:prstGeom prst="straightConnector1">
+            <a:avLst/>
+          </a:prstGeom>
+          <a:ln w="19050">
+            <a:solidFill>
+              <a:schemeClr val="tx1"/>
+            </a:solidFill>
+            <a:tailEnd type="triangle"/>
+          </a:ln>
+        </p:spPr>
+        <p:style>
+          <a:lnRef idx="1">
+            <a:schemeClr val="accent1"/>
+          </a:lnRef>
+          <a:fillRef idx="0">
+            <a:schemeClr val="accent1"/>
+          </a:fillRef>
+          <a:effectRef idx="0">
+            <a:schemeClr val="accent1"/>
+          </a:effectRef>
+          <a:fontRef idx="minor">
+            <a:schemeClr val="tx1"/>
+          </a:fontRef>
+        </p:style>
+      </p:cxnSp>
+      <p:sp>
+        <p:nvSpPr>
+          <p:cNvPr id="59" name="Rectangle 58">
+            <a:extLst>
+              <a:ext uri="{FF2B5EF4-FFF2-40B4-BE49-F238E27FC236}">
+                <a16:creationId xmlns:a16="http://schemas.microsoft.com/office/drawing/2014/main" id="{8C5D2CE2-94AB-0589-BE3A-881BDEB9383A}"/>
+              </a:ext>
+            </a:extLst>
+          </p:cNvPr>
+          <p:cNvSpPr/>
+          <p:nvPr/>
+        </p:nvSpPr>
+        <p:spPr>
+          <a:xfrm>
+            <a:off x="4873567" y="3393174"/>
+            <a:ext cx="765907" cy="749885"/>
+          </a:xfrm>
+          <a:prstGeom prst="rect">
+            <a:avLst/>
+          </a:prstGeom>
+          <a:solidFill>
+            <a:schemeClr val="bg1"/>
+          </a:solidFill>
+          <a:ln w="19050">
+            <a:solidFill>
+              <a:schemeClr val="tx1"/>
+            </a:solidFill>
+          </a:ln>
+        </p:spPr>
+        <p:style>
+          <a:lnRef idx="2">
+            <a:schemeClr val="accent1">
+              <a:shade val="50000"/>
+            </a:schemeClr>
+          </a:lnRef>
+          <a:fillRef idx="1">
+            <a:schemeClr val="accent1"/>
+          </a:fillRef>
+          <a:effectRef idx="0">
+            <a:schemeClr val="accent1"/>
+          </a:effectRef>
+          <a:fontRef idx="minor">
+            <a:schemeClr val="lt1"/>
+          </a:fontRef>
+        </p:style>
+        <p:txBody>
+          <a:bodyPr rot="0" spcFirstLastPara="0" vertOverflow="overflow" horzOverflow="overflow" vert="horz" wrap="square" lIns="53996" tIns="26998" rIns="53996" bIns="26998" numCol="1" spcCol="0" rtlCol="0" fromWordArt="0" anchor="ctr" anchorCtr="0" forceAA="0" compatLnSpc="1">
+            <a:prstTxWarp prst="textNoShape">
+              <a:avLst/>
+            </a:prstTxWarp>
+            <a:noAutofit/>
+          </a:bodyPr>
+          <a:lstStyle/>
+          <a:p>
+            <a:pPr algn="ctr"/>
+            <a:r>
+              <a:rPr lang="en-US" dirty="0">
+                <a:solidFill>
+                  <a:schemeClr val="tx1"/>
+                </a:solidFill>
+                <a:latin typeface="Times New Roman" panose="02020603050405020304" pitchFamily="18" charset="0"/>
+                <a:cs typeface="Times New Roman" panose="02020603050405020304" pitchFamily="18" charset="0"/>
+              </a:rPr>
+              <a:t>S1</a:t>
+            </a:r>
+          </a:p>
+        </p:txBody>
+      </p:sp>
+      <p:sp>
+        <p:nvSpPr>
+          <p:cNvPr id="60" name="Oval 59">
+            <a:extLst>
+              <a:ext uri="{FF2B5EF4-FFF2-40B4-BE49-F238E27FC236}">
+                <a16:creationId xmlns:a16="http://schemas.microsoft.com/office/drawing/2014/main" id="{0CE32EEE-BB03-6607-BC61-3DEE8E377BAC}"/>
+              </a:ext>
+            </a:extLst>
+          </p:cNvPr>
+          <p:cNvSpPr>
+            <a:spLocks noChangeAspect="1"/>
+          </p:cNvSpPr>
+          <p:nvPr/>
+        </p:nvSpPr>
+        <p:spPr>
+          <a:xfrm>
+            <a:off x="4921397" y="4416647"/>
+            <a:ext cx="680891" cy="666648"/>
+          </a:xfrm>
+          <a:prstGeom prst="ellipse">
+            <a:avLst/>
+          </a:prstGeom>
+          <a:solidFill>
+            <a:schemeClr val="bg1"/>
+          </a:solidFill>
+          <a:ln w="19050">
+            <a:solidFill>
+              <a:schemeClr val="tx1"/>
+            </a:solidFill>
+          </a:ln>
+        </p:spPr>
+        <p:style>
+          <a:lnRef idx="2">
+            <a:schemeClr val="accent1">
+              <a:shade val="50000"/>
+            </a:schemeClr>
+          </a:lnRef>
+          <a:fillRef idx="1">
+            <a:schemeClr val="accent1"/>
+          </a:fillRef>
+          <a:effectRef idx="0">
+            <a:schemeClr val="accent1"/>
+          </a:effectRef>
+          <a:fontRef idx="minor">
+            <a:schemeClr val="lt1"/>
+          </a:fontRef>
+        </p:style>
+        <p:txBody>
+          <a:bodyPr rtlCol="0" anchor="ctr"/>
+          <a:lstStyle/>
+          <a:p>
+            <a:pPr algn="ctr"/>
+            <a:r>
+              <a:rPr lang="en-US" sz="1600" dirty="0">
+                <a:solidFill>
+                  <a:schemeClr val="tx1"/>
+                </a:solidFill>
+                <a:latin typeface="Times New Roman" panose="02020603050405020304" pitchFamily="18" charset="0"/>
+                <a:cs typeface="Times New Roman" panose="02020603050405020304" pitchFamily="18" charset="0"/>
+              </a:rPr>
+              <a:t>u</a:t>
+            </a:r>
+            <a:r>
+              <a:rPr lang="en-US" sz="1600" baseline="-25000" dirty="0">
+                <a:solidFill>
+                  <a:schemeClr val="tx1"/>
+                </a:solidFill>
+                <a:latin typeface="Times New Roman" panose="02020603050405020304" pitchFamily="18" charset="0"/>
+                <a:cs typeface="Times New Roman" panose="02020603050405020304" pitchFamily="18" charset="0"/>
+              </a:rPr>
+              <a:t>S1</a:t>
+            </a:r>
+            <a:endParaRPr lang="en-US" sz="1600" dirty="0">
+              <a:solidFill>
+                <a:schemeClr val="tx1"/>
+              </a:solidFill>
+              <a:latin typeface="Times New Roman" panose="02020603050405020304" pitchFamily="18" charset="0"/>
+              <a:cs typeface="Times New Roman" panose="02020603050405020304" pitchFamily="18" charset="0"/>
+            </a:endParaRPr>
+          </a:p>
+        </p:txBody>
+      </p:sp>
+      <p:cxnSp>
+        <p:nvCxnSpPr>
+          <p:cNvPr id="61" name="Straight Arrow Connector 60">
+            <a:extLst>
+              <a:ext uri="{FF2B5EF4-FFF2-40B4-BE49-F238E27FC236}">
+                <a16:creationId xmlns:a16="http://schemas.microsoft.com/office/drawing/2014/main" id="{0E481BEE-C6B5-A31F-A5A4-C1D3A86D72C5}"/>
+              </a:ext>
+            </a:extLst>
+          </p:cNvPr>
+          <p:cNvCxnSpPr>
+            <a:cxnSpLocks/>
+            <a:stCxn id="59" idx="2"/>
+            <a:endCxn id="60" idx="0"/>
+          </p:cNvCxnSpPr>
+          <p:nvPr/>
+        </p:nvCxnSpPr>
+        <p:spPr>
+          <a:xfrm>
+            <a:off x="5256521" y="4143059"/>
+            <a:ext cx="5322" cy="273588"/>
+          </a:xfrm>
+          <a:prstGeom prst="straightConnector1">
+            <a:avLst/>
+          </a:prstGeom>
+          <a:ln w="19050">
+            <a:solidFill>
+              <a:schemeClr val="tx1"/>
+            </a:solidFill>
+            <a:headEnd type="triangle" w="med" len="med"/>
+            <a:tailEnd type="none" w="med" len="med"/>
+          </a:ln>
+        </p:spPr>
+        <p:style>
+          <a:lnRef idx="1">
+            <a:schemeClr val="accent1"/>
+          </a:lnRef>
+          <a:fillRef idx="0">
+            <a:schemeClr val="accent1"/>
+          </a:fillRef>
+          <a:effectRef idx="0">
+            <a:schemeClr val="accent1"/>
+          </a:effectRef>
+          <a:fontRef idx="minor">
+            <a:schemeClr val="tx1"/>
+          </a:fontRef>
+        </p:style>
+      </p:cxnSp>
+      <p:cxnSp>
+        <p:nvCxnSpPr>
+          <p:cNvPr id="70" name="Straight Arrow Connector 69">
+            <a:extLst>
+              <a:ext uri="{FF2B5EF4-FFF2-40B4-BE49-F238E27FC236}">
+                <a16:creationId xmlns:a16="http://schemas.microsoft.com/office/drawing/2014/main" id="{8561935E-2FE0-388A-F3E1-04B0BE5F333B}"/>
+              </a:ext>
+            </a:extLst>
+          </p:cNvPr>
+          <p:cNvCxnSpPr>
+            <a:cxnSpLocks/>
+            <a:stCxn id="43" idx="4"/>
+            <a:endCxn id="59" idx="0"/>
+          </p:cNvCxnSpPr>
+          <p:nvPr/>
+        </p:nvCxnSpPr>
+        <p:spPr>
+          <a:xfrm flipH="1">
+            <a:off x="5256521" y="2450784"/>
+            <a:ext cx="1297264" cy="942390"/>
+          </a:xfrm>
+          <a:prstGeom prst="straightConnector1">
+            <a:avLst/>
+          </a:prstGeom>
+          <a:ln w="19050">
+            <a:solidFill>
+              <a:schemeClr val="tx1"/>
+            </a:solidFill>
+            <a:tailEnd type="triangle"/>
+          </a:ln>
+        </p:spPr>
+        <p:style>
+          <a:lnRef idx="1">
+            <a:schemeClr val="accent1"/>
+          </a:lnRef>
+          <a:fillRef idx="0">
+            <a:schemeClr val="accent1"/>
+          </a:fillRef>
+          <a:effectRef idx="0">
+            <a:schemeClr val="accent1"/>
+          </a:effectRef>
+          <a:fontRef idx="minor">
+            <a:schemeClr val="tx1"/>
+          </a:fontRef>
+        </p:style>
+      </p:cxnSp>
+      <p:cxnSp>
+        <p:nvCxnSpPr>
+          <p:cNvPr id="116" name="Connector: Curved 115">
+            <a:extLst>
+              <a:ext uri="{FF2B5EF4-FFF2-40B4-BE49-F238E27FC236}">
+                <a16:creationId xmlns:a16="http://schemas.microsoft.com/office/drawing/2014/main" id="{ED34FDB0-98C7-ABAF-F350-A58E1143C9AF}"/>
+              </a:ext>
+            </a:extLst>
+          </p:cNvPr>
+          <p:cNvCxnSpPr>
+            <a:cxnSpLocks/>
+            <a:stCxn id="91" idx="0"/>
+            <a:endCxn id="43" idx="0"/>
+          </p:cNvCxnSpPr>
+          <p:nvPr/>
+        </p:nvCxnSpPr>
+        <p:spPr>
+          <a:xfrm rot="5400000" flipH="1" flipV="1">
+            <a:off x="4365206" y="-1337745"/>
+            <a:ext cx="12700" cy="4377155"/>
+          </a:xfrm>
+          <a:prstGeom prst="curvedConnector3">
+            <a:avLst>
+              <a:gd name="adj1" fmla="val 5025000"/>
+            </a:avLst>
+          </a:prstGeom>
+          <a:ln w="19050">
+            <a:solidFill>
+              <a:schemeClr val="tx1"/>
+            </a:solidFill>
+            <a:headEnd type="triangle"/>
+            <a:tailEnd type="triangle"/>
+          </a:ln>
+        </p:spPr>
+        <p:style>
+          <a:lnRef idx="1">
+            <a:schemeClr val="accent1"/>
+          </a:lnRef>
+          <a:fillRef idx="0">
+            <a:schemeClr val="accent1"/>
+          </a:fillRef>
+          <a:effectRef idx="0">
+            <a:schemeClr val="accent1"/>
+          </a:effectRef>
+          <a:fontRef idx="minor">
+            <a:schemeClr val="tx1"/>
+          </a:fontRef>
+        </p:style>
+      </p:cxnSp>
     </p:spTree>
     <p:extLst>
       <p:ext uri="{BB962C8B-B14F-4D97-AF65-F5344CB8AC3E}">

</xml_diff>